<commit_message>
Expand soutenance materials and update women images
</commit_message>
<xml_diff>
--- a/docs/presentation_soutenance_boutique.pptx
+++ b/docs/presentation_soutenance_boutique.pptx
@@ -12,6 +12,12 @@
     <p:sldId id="260" r:id="rId11"/>
     <p:sldId id="261" r:id="rId12"/>
     <p:sldId id="262" r:id="rId13"/>
+    <p:sldId id="263" r:id="rId14"/>
+    <p:sldId id="264" r:id="rId15"/>
+    <p:sldId id="265" r:id="rId16"/>
+    <p:sldId id="266" r:id="rId17"/>
+    <p:sldId id="267" r:id="rId18"/>
+    <p:sldId id="268" r:id="rId19"/>
   </p:sldIdLst>
   <p:sldSz cx="12191695" cy="6858000" type="screen4x3"/>
   <p:notesSz cx="6858000" cy="9144000"/>
@@ -3111,7 +3117,7 @@
         <p:spPr>
           <a:xfrm>
             <a:off x="594360" y="777240"/>
-            <a:ext cx="1371600" cy="109728"/>
+            <a:ext cx="1463040" cy="109728"/>
           </a:xfrm>
           <a:prstGeom prst="rect">
             <a:avLst/>
@@ -3153,8 +3159,8 @@
         </p:nvSpPr>
         <p:spPr>
           <a:xfrm>
-            <a:off x="594360" y="1097280"/>
-            <a:ext cx="8046720" cy="1371600"/>
+            <a:off x="594360" y="1051560"/>
+            <a:ext cx="8046720" cy="1463040"/>
           </a:xfrm>
           <a:prstGeom prst="rect">
             <a:avLst/>
@@ -3167,8 +3173,9 @@
           </a:bodyPr>
           <a:lstStyle/>
           <a:p>
-            <a:r>
-              <a:rPr sz="2800" b="1">
+            <a:pPr algn="l"/>
+            <a:r>
+              <a:rPr sz="2800">
                 <a:solidFill>
                   <a:srgbClr val="FFFFFF"/>
                 </a:solidFill>
@@ -3188,7 +3195,7 @@
         <p:spPr>
           <a:xfrm>
             <a:off x="621792" y="2743200"/>
-            <a:ext cx="6949440" cy="1097280"/>
+            <a:ext cx="7498079" cy="914400"/>
           </a:xfrm>
           <a:prstGeom prst="rect">
             <a:avLst/>
@@ -3201,6 +3208,7 @@
           </a:bodyPr>
           <a:lstStyle/>
           <a:p>
+            <a:pPr algn="l"/>
             <a:r>
               <a:rPr sz="1800">
                 <a:solidFill>
@@ -3209,6 +3217,1276 @@
               </a:rPr>
               <a:t>Cours : Management des donnees et innovation
 Equipe : Zeinabou, Assia, Awa, Alexis, Chloe</a:t>
+            </a:r>
+          </a:p>
+        </p:txBody>
+      </p:sp>
+      <p:sp>
+        <p:nvSpPr>
+          <p:cNvPr id="5" name="TextBox 4"/>
+          <p:cNvSpPr txBox="1"/>
+          <p:nvPr/>
+        </p:nvSpPr>
+        <p:spPr>
+          <a:xfrm>
+            <a:off x="621792" y="4023360"/>
+            <a:ext cx="7132320" cy="548640"/>
+          </a:xfrm>
+          <a:prstGeom prst="rect">
+            <a:avLst/>
+          </a:prstGeom>
+          <a:noFill/>
+        </p:spPr>
+        <p:txBody>
+          <a:bodyPr wrap="none">
+            <a:spAutoFit/>
+          </a:bodyPr>
+          <a:lstStyle/>
+          <a:p>
+            <a:pPr algn="l"/>
+            <a:r>
+              <a:rPr sz="1400">
+                <a:solidFill>
+                  <a:srgbClr val="D1D5DB"/>
+                </a:solidFill>
+              </a:rPr>
+              <a:t>Soutenance : objectif, fonctionnement, code, demo, difficultes</a:t>
+            </a:r>
+          </a:p>
+        </p:txBody>
+      </p:sp>
+    </p:spTree>
+  </p:cSld>
+  <p:clrMapOvr>
+    <a:masterClrMapping/>
+  </p:clrMapOvr>
+</p:sld>
+</file>
+
+<file path=ppt/slides/slide10.xml><?xml version="1.0" encoding="utf-8"?>
+<p:sld xmlns:a="http://schemas.openxmlformats.org/drawingml/2006/main" xmlns:p="http://schemas.openxmlformats.org/presentationml/2006/main" xmlns:r="http://schemas.openxmlformats.org/officeDocument/2006/relationships">
+  <p:cSld>
+    <p:bg>
+      <p:bgPr>
+        <a:solidFill>
+          <a:srgbClr val="F7F9FC"/>
+        </a:solidFill>
+        <a:effectLst/>
+      </p:bgPr>
+    </p:bg>
+    <p:spTree>
+      <p:nvGrpSpPr>
+        <p:cNvPr id="1" name=""/>
+        <p:cNvGrpSpPr/>
+        <p:nvPr/>
+      </p:nvGrpSpPr>
+      <p:grpSpPr/>
+      <p:sp>
+        <p:nvSpPr>
+          <p:cNvPr id="2" name="Rectangle 1"/>
+          <p:cNvSpPr/>
+          <p:nvPr/>
+        </p:nvSpPr>
+        <p:spPr>
+          <a:xfrm>
+            <a:off x="0" y="0"/>
+            <a:ext cx="12191695" cy="914400"/>
+          </a:xfrm>
+          <a:prstGeom prst="rect">
+            <a:avLst/>
+          </a:prstGeom>
+          <a:solidFill>
+            <a:srgbClr val="111827"/>
+          </a:solidFill>
+          <a:ln>
+            <a:noFill/>
+          </a:ln>
+        </p:spPr>
+        <p:style>
+          <a:lnRef idx="1">
+            <a:schemeClr val="accent1"/>
+          </a:lnRef>
+          <a:fillRef idx="3">
+            <a:schemeClr val="accent1"/>
+          </a:fillRef>
+          <a:effectRef idx="2">
+            <a:schemeClr val="accent1"/>
+          </a:effectRef>
+          <a:fontRef idx="minor">
+            <a:schemeClr val="lt1"/>
+          </a:fontRef>
+        </p:style>
+        <p:txBody>
+          <a:bodyPr rtlCol="0" anchor="ctr"/>
+          <a:lstStyle/>
+          <a:p>
+            <a:pPr algn="ctr"/>
+          </a:p>
+        </p:txBody>
+      </p:sp>
+      <p:sp>
+        <p:nvSpPr>
+          <p:cNvPr id="3" name="TextBox 2"/>
+          <p:cNvSpPr txBox="1"/>
+          <p:nvPr/>
+        </p:nvSpPr>
+        <p:spPr>
+          <a:xfrm>
+            <a:off x="548640" y="182880"/>
+            <a:ext cx="8961120" cy="320040"/>
+          </a:xfrm>
+          <a:prstGeom prst="rect">
+            <a:avLst/>
+          </a:prstGeom>
+          <a:noFill/>
+        </p:spPr>
+        <p:txBody>
+          <a:bodyPr wrap="none">
+            <a:spAutoFit/>
+          </a:bodyPr>
+          <a:lstStyle/>
+          <a:p>
+            <a:r>
+              <a:rPr sz="2400" b="1">
+                <a:solidFill>
+                  <a:srgbClr val="FFFFFF"/>
+                </a:solidFill>
+              </a:rPr>
+              <a:t>Captures de demonstration client</a:t>
+            </a:r>
+          </a:p>
+        </p:txBody>
+      </p:sp>
+      <p:sp>
+        <p:nvSpPr>
+          <p:cNvPr id="4" name="Rounded Rectangle 3"/>
+          <p:cNvSpPr/>
+          <p:nvPr/>
+        </p:nvSpPr>
+        <p:spPr>
+          <a:xfrm>
+            <a:off x="502920" y="1325880"/>
+            <a:ext cx="3474720" cy="4617720"/>
+          </a:xfrm>
+          <a:prstGeom prst="roundRect">
+            <a:avLst/>
+          </a:prstGeom>
+          <a:solidFill>
+            <a:srgbClr val="FFFFFF"/>
+          </a:solidFill>
+          <a:ln>
+            <a:solidFill>
+              <a:srgbClr val="E2E8F0"/>
+            </a:solidFill>
+          </a:ln>
+        </p:spPr>
+        <p:style>
+          <a:lnRef idx="1">
+            <a:schemeClr val="accent1"/>
+          </a:lnRef>
+          <a:fillRef idx="3">
+            <a:schemeClr val="accent1"/>
+          </a:fillRef>
+          <a:effectRef idx="2">
+            <a:schemeClr val="accent1"/>
+          </a:effectRef>
+          <a:fontRef idx="minor">
+            <a:schemeClr val="lt1"/>
+          </a:fontRef>
+        </p:style>
+        <p:txBody>
+          <a:bodyPr rtlCol="0" anchor="ctr"/>
+          <a:lstStyle/>
+          <a:p>
+            <a:pPr algn="ctr"/>
+          </a:p>
+        </p:txBody>
+      </p:sp>
+      <p:pic>
+        <p:nvPicPr>
+          <p:cNvPr id="5" name="Picture 4" descr="01-login-page.png"/>
+          <p:cNvPicPr>
+            <a:picLocks noChangeAspect="1"/>
+          </p:cNvPicPr>
+          <p:nvPr/>
+        </p:nvPicPr>
+        <p:blipFill>
+          <a:blip r:embed="rId2"/>
+          <a:stretch>
+            <a:fillRect/>
+          </a:stretch>
+        </p:blipFill>
+        <p:spPr>
+          <a:xfrm>
+            <a:off x="612648" y="1435608"/>
+            <a:ext cx="3255264" cy="4206240"/>
+          </a:xfrm>
+          <a:prstGeom prst="rect">
+            <a:avLst/>
+          </a:prstGeom>
+        </p:spPr>
+      </p:pic>
+      <p:sp>
+        <p:nvSpPr>
+          <p:cNvPr id="6" name="TextBox 5"/>
+          <p:cNvSpPr txBox="1"/>
+          <p:nvPr/>
+        </p:nvSpPr>
+        <p:spPr>
+          <a:xfrm>
+            <a:off x="502920" y="5687568"/>
+            <a:ext cx="3474720" cy="320040"/>
+          </a:xfrm>
+          <a:prstGeom prst="rect">
+            <a:avLst/>
+          </a:prstGeom>
+          <a:noFill/>
+        </p:spPr>
+        <p:txBody>
+          <a:bodyPr wrap="none">
+            <a:spAutoFit/>
+          </a:bodyPr>
+          <a:lstStyle/>
+          <a:p>
+            <a:pPr algn="ctr"/>
+            <a:r>
+              <a:rPr sz="1200">
+                <a:solidFill>
+                  <a:srgbClr val="4B5563"/>
+                </a:solidFill>
+              </a:rPr>
+              <a:t>Connexion</a:t>
+            </a:r>
+          </a:p>
+        </p:txBody>
+      </p:sp>
+      <p:sp>
+        <p:nvSpPr>
+          <p:cNvPr id="7" name="Rounded Rectangle 6"/>
+          <p:cNvSpPr/>
+          <p:nvPr/>
+        </p:nvSpPr>
+        <p:spPr>
+          <a:xfrm>
+            <a:off x="4160520" y="1325880"/>
+            <a:ext cx="3840480" cy="4617720"/>
+          </a:xfrm>
+          <a:prstGeom prst="roundRect">
+            <a:avLst/>
+          </a:prstGeom>
+          <a:solidFill>
+            <a:srgbClr val="FFFFFF"/>
+          </a:solidFill>
+          <a:ln>
+            <a:solidFill>
+              <a:srgbClr val="E2E8F0"/>
+            </a:solidFill>
+          </a:ln>
+        </p:spPr>
+        <p:style>
+          <a:lnRef idx="1">
+            <a:schemeClr val="accent1"/>
+          </a:lnRef>
+          <a:fillRef idx="3">
+            <a:schemeClr val="accent1"/>
+          </a:fillRef>
+          <a:effectRef idx="2">
+            <a:schemeClr val="accent1"/>
+          </a:effectRef>
+          <a:fontRef idx="minor">
+            <a:schemeClr val="lt1"/>
+          </a:fontRef>
+        </p:style>
+        <p:txBody>
+          <a:bodyPr rtlCol="0" anchor="ctr"/>
+          <a:lstStyle/>
+          <a:p>
+            <a:pPr algn="ctr"/>
+          </a:p>
+        </p:txBody>
+      </p:sp>
+      <p:pic>
+        <p:nvPicPr>
+          <p:cNvPr id="8" name="Picture 7" descr="02-catalogue-client.png"/>
+          <p:cNvPicPr>
+            <a:picLocks noChangeAspect="1"/>
+          </p:cNvPicPr>
+          <p:nvPr/>
+        </p:nvPicPr>
+        <p:blipFill>
+          <a:blip r:embed="rId3"/>
+          <a:stretch>
+            <a:fillRect/>
+          </a:stretch>
+        </p:blipFill>
+        <p:spPr>
+          <a:xfrm>
+            <a:off x="4270248" y="1435608"/>
+            <a:ext cx="3621024" cy="4206240"/>
+          </a:xfrm>
+          <a:prstGeom prst="rect">
+            <a:avLst/>
+          </a:prstGeom>
+        </p:spPr>
+      </p:pic>
+      <p:sp>
+        <p:nvSpPr>
+          <p:cNvPr id="9" name="TextBox 8"/>
+          <p:cNvSpPr txBox="1"/>
+          <p:nvPr/>
+        </p:nvSpPr>
+        <p:spPr>
+          <a:xfrm>
+            <a:off x="4160520" y="5687568"/>
+            <a:ext cx="3840480" cy="320040"/>
+          </a:xfrm>
+          <a:prstGeom prst="rect">
+            <a:avLst/>
+          </a:prstGeom>
+          <a:noFill/>
+        </p:spPr>
+        <p:txBody>
+          <a:bodyPr wrap="none">
+            <a:spAutoFit/>
+          </a:bodyPr>
+          <a:lstStyle/>
+          <a:p>
+            <a:pPr algn="ctr"/>
+            <a:r>
+              <a:rPr sz="1200">
+                <a:solidFill>
+                  <a:srgbClr val="4B5563"/>
+                </a:solidFill>
+              </a:rPr>
+              <a:t>Catalogue</a:t>
+            </a:r>
+          </a:p>
+        </p:txBody>
+      </p:sp>
+      <p:sp>
+        <p:nvSpPr>
+          <p:cNvPr id="10" name="Rounded Rectangle 9"/>
+          <p:cNvSpPr/>
+          <p:nvPr/>
+        </p:nvSpPr>
+        <p:spPr>
+          <a:xfrm>
+            <a:off x="8183879" y="1325880"/>
+            <a:ext cx="3474720" cy="4617720"/>
+          </a:xfrm>
+          <a:prstGeom prst="roundRect">
+            <a:avLst/>
+          </a:prstGeom>
+          <a:solidFill>
+            <a:srgbClr val="FFFFFF"/>
+          </a:solidFill>
+          <a:ln>
+            <a:solidFill>
+              <a:srgbClr val="E2E8F0"/>
+            </a:solidFill>
+          </a:ln>
+        </p:spPr>
+        <p:style>
+          <a:lnRef idx="1">
+            <a:schemeClr val="accent1"/>
+          </a:lnRef>
+          <a:fillRef idx="3">
+            <a:schemeClr val="accent1"/>
+          </a:fillRef>
+          <a:effectRef idx="2">
+            <a:schemeClr val="accent1"/>
+          </a:effectRef>
+          <a:fontRef idx="minor">
+            <a:schemeClr val="lt1"/>
+          </a:fontRef>
+        </p:style>
+        <p:txBody>
+          <a:bodyPr rtlCol="0" anchor="ctr"/>
+          <a:lstStyle/>
+          <a:p>
+            <a:pPr algn="ctr"/>
+          </a:p>
+        </p:txBody>
+      </p:sp>
+      <p:pic>
+        <p:nvPicPr>
+          <p:cNvPr id="11" name="Picture 10" descr="03-achat-page.png"/>
+          <p:cNvPicPr>
+            <a:picLocks noChangeAspect="1"/>
+          </p:cNvPicPr>
+          <p:nvPr/>
+        </p:nvPicPr>
+        <p:blipFill>
+          <a:blip r:embed="rId4"/>
+          <a:stretch>
+            <a:fillRect/>
+          </a:stretch>
+        </p:blipFill>
+        <p:spPr>
+          <a:xfrm>
+            <a:off x="8293607" y="1435608"/>
+            <a:ext cx="3255264" cy="4206240"/>
+          </a:xfrm>
+          <a:prstGeom prst="rect">
+            <a:avLst/>
+          </a:prstGeom>
+        </p:spPr>
+      </p:pic>
+      <p:sp>
+        <p:nvSpPr>
+          <p:cNvPr id="12" name="TextBox 11"/>
+          <p:cNvSpPr txBox="1"/>
+          <p:nvPr/>
+        </p:nvSpPr>
+        <p:spPr>
+          <a:xfrm>
+            <a:off x="8183879" y="5687568"/>
+            <a:ext cx="3474720" cy="320040"/>
+          </a:xfrm>
+          <a:prstGeom prst="rect">
+            <a:avLst/>
+          </a:prstGeom>
+          <a:noFill/>
+        </p:spPr>
+        <p:txBody>
+          <a:bodyPr wrap="none">
+            <a:spAutoFit/>
+          </a:bodyPr>
+          <a:lstStyle/>
+          <a:p>
+            <a:pPr algn="ctr"/>
+            <a:r>
+              <a:rPr sz="1200">
+                <a:solidFill>
+                  <a:srgbClr val="4B5563"/>
+                </a:solidFill>
+              </a:rPr>
+              <a:t>Achat</a:t>
+            </a:r>
+          </a:p>
+        </p:txBody>
+      </p:sp>
+    </p:spTree>
+  </p:cSld>
+  <p:clrMapOvr>
+    <a:masterClrMapping/>
+  </p:clrMapOvr>
+</p:sld>
+</file>
+
+<file path=ppt/slides/slide11.xml><?xml version="1.0" encoding="utf-8"?>
+<p:sld xmlns:a="http://schemas.openxmlformats.org/drawingml/2006/main" xmlns:p="http://schemas.openxmlformats.org/presentationml/2006/main" xmlns:r="http://schemas.openxmlformats.org/officeDocument/2006/relationships">
+  <p:cSld>
+    <p:bg>
+      <p:bgPr>
+        <a:solidFill>
+          <a:srgbClr val="F7F9FC"/>
+        </a:solidFill>
+        <a:effectLst/>
+      </p:bgPr>
+    </p:bg>
+    <p:spTree>
+      <p:nvGrpSpPr>
+        <p:cNvPr id="1" name=""/>
+        <p:cNvGrpSpPr/>
+        <p:nvPr/>
+      </p:nvGrpSpPr>
+      <p:grpSpPr/>
+      <p:sp>
+        <p:nvSpPr>
+          <p:cNvPr id="2" name="Rectangle 1"/>
+          <p:cNvSpPr/>
+          <p:nvPr/>
+        </p:nvSpPr>
+        <p:spPr>
+          <a:xfrm>
+            <a:off x="0" y="0"/>
+            <a:ext cx="12191695" cy="914400"/>
+          </a:xfrm>
+          <a:prstGeom prst="rect">
+            <a:avLst/>
+          </a:prstGeom>
+          <a:solidFill>
+            <a:srgbClr val="111827"/>
+          </a:solidFill>
+          <a:ln>
+            <a:noFill/>
+          </a:ln>
+        </p:spPr>
+        <p:style>
+          <a:lnRef idx="1">
+            <a:schemeClr val="accent1"/>
+          </a:lnRef>
+          <a:fillRef idx="3">
+            <a:schemeClr val="accent1"/>
+          </a:fillRef>
+          <a:effectRef idx="2">
+            <a:schemeClr val="accent1"/>
+          </a:effectRef>
+          <a:fontRef idx="minor">
+            <a:schemeClr val="lt1"/>
+          </a:fontRef>
+        </p:style>
+        <p:txBody>
+          <a:bodyPr rtlCol="0" anchor="ctr"/>
+          <a:lstStyle/>
+          <a:p>
+            <a:pPr algn="ctr"/>
+          </a:p>
+        </p:txBody>
+      </p:sp>
+      <p:sp>
+        <p:nvSpPr>
+          <p:cNvPr id="3" name="TextBox 2"/>
+          <p:cNvSpPr txBox="1"/>
+          <p:nvPr/>
+        </p:nvSpPr>
+        <p:spPr>
+          <a:xfrm>
+            <a:off x="548640" y="182880"/>
+            <a:ext cx="8961120" cy="320040"/>
+          </a:xfrm>
+          <a:prstGeom prst="rect">
+            <a:avLst/>
+          </a:prstGeom>
+          <a:noFill/>
+        </p:spPr>
+        <p:txBody>
+          <a:bodyPr wrap="none">
+            <a:spAutoFit/>
+          </a:bodyPr>
+          <a:lstStyle/>
+          <a:p>
+            <a:r>
+              <a:rPr sz="2400" b="1">
+                <a:solidFill>
+                  <a:srgbClr val="FFFFFF"/>
+                </a:solidFill>
+              </a:rPr>
+              <a:t>Verification du stock et gestion admin</a:t>
+            </a:r>
+          </a:p>
+        </p:txBody>
+      </p:sp>
+      <p:sp>
+        <p:nvSpPr>
+          <p:cNvPr id="4" name="Rounded Rectangle 3"/>
+          <p:cNvSpPr/>
+          <p:nvPr/>
+        </p:nvSpPr>
+        <p:spPr>
+          <a:xfrm>
+            <a:off x="685800" y="1371600"/>
+            <a:ext cx="5394960" cy="4572000"/>
+          </a:xfrm>
+          <a:prstGeom prst="roundRect">
+            <a:avLst/>
+          </a:prstGeom>
+          <a:solidFill>
+            <a:srgbClr val="FFFFFF"/>
+          </a:solidFill>
+          <a:ln>
+            <a:solidFill>
+              <a:srgbClr val="E2E8F0"/>
+            </a:solidFill>
+          </a:ln>
+        </p:spPr>
+        <p:style>
+          <a:lnRef idx="1">
+            <a:schemeClr val="accent1"/>
+          </a:lnRef>
+          <a:fillRef idx="3">
+            <a:schemeClr val="accent1"/>
+          </a:fillRef>
+          <a:effectRef idx="2">
+            <a:schemeClr val="accent1"/>
+          </a:effectRef>
+          <a:fontRef idx="minor">
+            <a:schemeClr val="lt1"/>
+          </a:fontRef>
+        </p:style>
+        <p:txBody>
+          <a:bodyPr rtlCol="0" anchor="ctr"/>
+          <a:lstStyle/>
+          <a:p>
+            <a:pPr algn="ctr"/>
+          </a:p>
+        </p:txBody>
+      </p:sp>
+      <p:pic>
+        <p:nvPicPr>
+          <p:cNvPr id="5" name="Picture 4" descr="04-stock-apres-achat.png"/>
+          <p:cNvPicPr>
+            <a:picLocks noChangeAspect="1"/>
+          </p:cNvPicPr>
+          <p:nvPr/>
+        </p:nvPicPr>
+        <p:blipFill>
+          <a:blip r:embed="rId2"/>
+          <a:stretch>
+            <a:fillRect/>
+          </a:stretch>
+        </p:blipFill>
+        <p:spPr>
+          <a:xfrm>
+            <a:off x="795528" y="1481328"/>
+            <a:ext cx="5175504" cy="4160520"/>
+          </a:xfrm>
+          <a:prstGeom prst="rect">
+            <a:avLst/>
+          </a:prstGeom>
+        </p:spPr>
+      </p:pic>
+      <p:sp>
+        <p:nvSpPr>
+          <p:cNvPr id="6" name="TextBox 5"/>
+          <p:cNvSpPr txBox="1"/>
+          <p:nvPr/>
+        </p:nvSpPr>
+        <p:spPr>
+          <a:xfrm>
+            <a:off x="685800" y="5687568"/>
+            <a:ext cx="5394960" cy="320040"/>
+          </a:xfrm>
+          <a:prstGeom prst="rect">
+            <a:avLst/>
+          </a:prstGeom>
+          <a:noFill/>
+        </p:spPr>
+        <p:txBody>
+          <a:bodyPr wrap="none">
+            <a:spAutoFit/>
+          </a:bodyPr>
+          <a:lstStyle/>
+          <a:p>
+            <a:pPr algn="ctr"/>
+            <a:r>
+              <a:rPr sz="1200">
+                <a:solidFill>
+                  <a:srgbClr val="4B5563"/>
+                </a:solidFill>
+              </a:rPr>
+              <a:t>Stock apres achat</a:t>
+            </a:r>
+          </a:p>
+        </p:txBody>
+      </p:sp>
+      <p:sp>
+        <p:nvSpPr>
+          <p:cNvPr id="7" name="Rounded Rectangle 6"/>
+          <p:cNvSpPr/>
+          <p:nvPr/>
+        </p:nvSpPr>
+        <p:spPr>
+          <a:xfrm>
+            <a:off x="6172200" y="1371600"/>
+            <a:ext cx="5394960" cy="4572000"/>
+          </a:xfrm>
+          <a:prstGeom prst="roundRect">
+            <a:avLst/>
+          </a:prstGeom>
+          <a:solidFill>
+            <a:srgbClr val="FFFFFF"/>
+          </a:solidFill>
+          <a:ln>
+            <a:solidFill>
+              <a:srgbClr val="E2E8F0"/>
+            </a:solidFill>
+          </a:ln>
+        </p:spPr>
+        <p:style>
+          <a:lnRef idx="1">
+            <a:schemeClr val="accent1"/>
+          </a:lnRef>
+          <a:fillRef idx="3">
+            <a:schemeClr val="accent1"/>
+          </a:fillRef>
+          <a:effectRef idx="2">
+            <a:schemeClr val="accent1"/>
+          </a:effectRef>
+          <a:fontRef idx="minor">
+            <a:schemeClr val="lt1"/>
+          </a:fontRef>
+        </p:style>
+        <p:txBody>
+          <a:bodyPr rtlCol="0" anchor="ctr"/>
+          <a:lstStyle/>
+          <a:p>
+            <a:pPr algn="ctr"/>
+          </a:p>
+        </p:txBody>
+      </p:sp>
+      <p:pic>
+        <p:nvPicPr>
+          <p:cNvPr id="8" name="Picture 7" descr="05-gestion-admin.png"/>
+          <p:cNvPicPr>
+            <a:picLocks noChangeAspect="1"/>
+          </p:cNvPicPr>
+          <p:nvPr/>
+        </p:nvPicPr>
+        <p:blipFill>
+          <a:blip r:embed="rId3"/>
+          <a:stretch>
+            <a:fillRect/>
+          </a:stretch>
+        </p:blipFill>
+        <p:spPr>
+          <a:xfrm>
+            <a:off x="6281928" y="1481328"/>
+            <a:ext cx="5175504" cy="4160520"/>
+          </a:xfrm>
+          <a:prstGeom prst="rect">
+            <a:avLst/>
+          </a:prstGeom>
+        </p:spPr>
+      </p:pic>
+      <p:sp>
+        <p:nvSpPr>
+          <p:cNvPr id="9" name="TextBox 8"/>
+          <p:cNvSpPr txBox="1"/>
+          <p:nvPr/>
+        </p:nvSpPr>
+        <p:spPr>
+          <a:xfrm>
+            <a:off x="6172200" y="5687568"/>
+            <a:ext cx="5394960" cy="320040"/>
+          </a:xfrm>
+          <a:prstGeom prst="rect">
+            <a:avLst/>
+          </a:prstGeom>
+          <a:noFill/>
+        </p:spPr>
+        <p:txBody>
+          <a:bodyPr wrap="none">
+            <a:spAutoFit/>
+          </a:bodyPr>
+          <a:lstStyle/>
+          <a:p>
+            <a:pPr algn="ctr"/>
+            <a:r>
+              <a:rPr sz="1200">
+                <a:solidFill>
+                  <a:srgbClr val="4B5563"/>
+                </a:solidFill>
+              </a:rPr>
+              <a:t>Gestion administrateur</a:t>
+            </a:r>
+          </a:p>
+        </p:txBody>
+      </p:sp>
+    </p:spTree>
+  </p:cSld>
+  <p:clrMapOvr>
+    <a:masterClrMapping/>
+  </p:clrMapOvr>
+</p:sld>
+</file>
+
+<file path=ppt/slides/slide12.xml><?xml version="1.0" encoding="utf-8"?>
+<p:sld xmlns:a="http://schemas.openxmlformats.org/drawingml/2006/main" xmlns:p="http://schemas.openxmlformats.org/presentationml/2006/main" xmlns:r="http://schemas.openxmlformats.org/officeDocument/2006/relationships">
+  <p:cSld>
+    <p:bg>
+      <p:bgPr>
+        <a:solidFill>
+          <a:srgbClr val="F7F9FC"/>
+        </a:solidFill>
+        <a:effectLst/>
+      </p:bgPr>
+    </p:bg>
+    <p:spTree>
+      <p:nvGrpSpPr>
+        <p:cNvPr id="1" name=""/>
+        <p:cNvGrpSpPr/>
+        <p:nvPr/>
+      </p:nvGrpSpPr>
+      <p:grpSpPr/>
+      <p:sp>
+        <p:nvSpPr>
+          <p:cNvPr id="2" name="Rectangle 1"/>
+          <p:cNvSpPr/>
+          <p:nvPr/>
+        </p:nvSpPr>
+        <p:spPr>
+          <a:xfrm>
+            <a:off x="0" y="0"/>
+            <a:ext cx="12191695" cy="914400"/>
+          </a:xfrm>
+          <a:prstGeom prst="rect">
+            <a:avLst/>
+          </a:prstGeom>
+          <a:solidFill>
+            <a:srgbClr val="111827"/>
+          </a:solidFill>
+          <a:ln>
+            <a:noFill/>
+          </a:ln>
+        </p:spPr>
+        <p:style>
+          <a:lnRef idx="1">
+            <a:schemeClr val="accent1"/>
+          </a:lnRef>
+          <a:fillRef idx="3">
+            <a:schemeClr val="accent1"/>
+          </a:fillRef>
+          <a:effectRef idx="2">
+            <a:schemeClr val="accent1"/>
+          </a:effectRef>
+          <a:fontRef idx="minor">
+            <a:schemeClr val="lt1"/>
+          </a:fontRef>
+        </p:style>
+        <p:txBody>
+          <a:bodyPr rtlCol="0" anchor="ctr"/>
+          <a:lstStyle/>
+          <a:p>
+            <a:pPr algn="ctr"/>
+          </a:p>
+        </p:txBody>
+      </p:sp>
+      <p:sp>
+        <p:nvSpPr>
+          <p:cNvPr id="3" name="TextBox 2"/>
+          <p:cNvSpPr txBox="1"/>
+          <p:nvPr/>
+        </p:nvSpPr>
+        <p:spPr>
+          <a:xfrm>
+            <a:off x="548640" y="182880"/>
+            <a:ext cx="8961120" cy="320040"/>
+          </a:xfrm>
+          <a:prstGeom prst="rect">
+            <a:avLst/>
+          </a:prstGeom>
+          <a:noFill/>
+        </p:spPr>
+        <p:txBody>
+          <a:bodyPr wrap="none">
+            <a:spAutoFit/>
+          </a:bodyPr>
+          <a:lstStyle/>
+          <a:p>
+            <a:r>
+              <a:rPr sz="2400" b="1">
+                <a:solidFill>
+                  <a:srgbClr val="FFFFFF"/>
+                </a:solidFill>
+              </a:rPr>
+              <a:t>Difficultes rencontrees et solutions</a:t>
+            </a:r>
+          </a:p>
+        </p:txBody>
+      </p:sp>
+      <p:sp>
+        <p:nvSpPr>
+          <p:cNvPr id="4" name="TextBox 3"/>
+          <p:cNvSpPr txBox="1"/>
+          <p:nvPr/>
+        </p:nvSpPr>
+        <p:spPr>
+          <a:xfrm>
+            <a:off x="822960" y="1371600"/>
+            <a:ext cx="5303520" cy="4389120"/>
+          </a:xfrm>
+          <a:prstGeom prst="rect">
+            <a:avLst/>
+          </a:prstGeom>
+          <a:noFill/>
+        </p:spPr>
+        <p:txBody>
+          <a:bodyPr wrap="square">
+            <a:spAutoFit/>
+          </a:bodyPr>
+          <a:lstStyle/>
+          <a:p>
+            <a:pPr>
+              <a:spcAft>
+                <a:spcPts val="700"/>
+              </a:spcAft>
+              <a:defRPr sz="1700">
+                <a:solidFill>
+                  <a:srgbClr val="111827"/>
+                </a:solidFill>
+              </a:defRPr>
+            </a:pPr>
+            <a:r>
+              <a:t>Integration de travaux venant de plusieurs membres.</a:t>
+            </a:r>
+          </a:p>
+          <a:p>
+            <a:pPr>
+              <a:spcAft>
+                <a:spcPts val="700"/>
+              </a:spcAft>
+              <a:defRPr sz="1700">
+                <a:solidFill>
+                  <a:srgbClr val="111827"/>
+                </a:solidFill>
+              </a:defRPr>
+            </a:pPr>
+            <a:r>
+              <a:t>Certains fichiers externes n'etaient pas dans GitHub au debut.</a:t>
+            </a:r>
+          </a:p>
+          <a:p>
+            <a:pPr>
+              <a:spcAft>
+                <a:spcPts val="700"/>
+              </a:spcAft>
+              <a:defRPr sz="1700">
+                <a:solidFill>
+                  <a:srgbClr val="111827"/>
+                </a:solidFill>
+              </a:defRPr>
+            </a:pPr>
+            <a:r>
+              <a:t>Nettoyage des noms d'images et correspondance avec les categories.</a:t>
+            </a:r>
+          </a:p>
+          <a:p>
+            <a:pPr>
+              <a:spcAft>
+                <a:spcPts val="700"/>
+              </a:spcAft>
+              <a:defRPr sz="1700">
+                <a:solidFill>
+                  <a:srgbClr val="111827"/>
+                </a:solidFill>
+              </a:defRPr>
+            </a:pPr>
+            <a:r>
+              <a:t>Adaptation de maquettes HTML/CSS dans une vraie structure Django.</a:t>
+            </a:r>
+          </a:p>
+          <a:p>
+            <a:pPr>
+              <a:spcAft>
+                <a:spcPts val="700"/>
+              </a:spcAft>
+              <a:defRPr sz="1700">
+                <a:solidFill>
+                  <a:srgbClr val="111827"/>
+                </a:solidFill>
+              </a:defRPr>
+            </a:pPr>
+            <a:r>
+              <a:t>Verification du stock pour eviter les erreurs d'achat.</a:t>
+            </a:r>
+          </a:p>
+        </p:txBody>
+      </p:sp>
+      <p:sp>
+        <p:nvSpPr>
+          <p:cNvPr id="5" name="TextBox 4"/>
+          <p:cNvSpPr txBox="1"/>
+          <p:nvPr/>
+        </p:nvSpPr>
+        <p:spPr>
+          <a:xfrm>
+            <a:off x="6035040" y="1371600"/>
+            <a:ext cx="5029200" cy="4389120"/>
+          </a:xfrm>
+          <a:prstGeom prst="rect">
+            <a:avLst/>
+          </a:prstGeom>
+          <a:noFill/>
+        </p:spPr>
+        <p:txBody>
+          <a:bodyPr wrap="square">
+            <a:spAutoFit/>
+          </a:bodyPr>
+          <a:lstStyle/>
+          <a:p>
+            <a:pPr>
+              <a:spcAft>
+                <a:spcPts val="700"/>
+              </a:spcAft>
+              <a:defRPr sz="1700">
+                <a:solidFill>
+                  <a:srgbClr val="111827"/>
+                </a:solidFill>
+              </a:defRPr>
+            </a:pPr>
+            <a:r>
+              <a:t>Solution : integration finale et verification globale du projet.</a:t>
+            </a:r>
+          </a:p>
+          <a:p>
+            <a:pPr>
+              <a:spcAft>
+                <a:spcPts val="700"/>
+              </a:spcAft>
+              <a:defRPr sz="1700">
+                <a:solidFill>
+                  <a:srgbClr val="111827"/>
+                </a:solidFill>
+              </a:defRPr>
+            </a:pPr>
+            <a:r>
+              <a:t>Solution : tests automatiques et parcours verifies manuellement.</a:t>
+            </a:r>
+          </a:p>
+          <a:p>
+            <a:pPr>
+              <a:spcAft>
+                <a:spcPts val="700"/>
+              </a:spcAft>
+              <a:defRPr sz="1700">
+                <a:solidFill>
+                  <a:srgbClr val="111827"/>
+                </a:solidFill>
+              </a:defRPr>
+            </a:pPr>
+            <a:r>
+              <a:t>Solution : rangement des assets et mise a jour des chemins.</a:t>
+            </a:r>
+          </a:p>
+          <a:p>
+            <a:pPr>
+              <a:spcAft>
+                <a:spcPts val="700"/>
+              </a:spcAft>
+              <a:defRPr sz="1700">
+                <a:solidFill>
+                  <a:srgbClr val="111827"/>
+                </a:solidFill>
+              </a:defRPr>
+            </a:pPr>
+            <a:r>
+              <a:t>Solution : README, PDF, captures et PowerPoint prepares.</a:t>
+            </a:r>
+          </a:p>
+        </p:txBody>
+      </p:sp>
+    </p:spTree>
+  </p:cSld>
+  <p:clrMapOvr>
+    <a:masterClrMapping/>
+  </p:clrMapOvr>
+</p:sld>
+</file>
+
+<file path=ppt/slides/slide13.xml><?xml version="1.0" encoding="utf-8"?>
+<p:sld xmlns:a="http://schemas.openxmlformats.org/drawingml/2006/main" xmlns:p="http://schemas.openxmlformats.org/presentationml/2006/main" xmlns:r="http://schemas.openxmlformats.org/officeDocument/2006/relationships">
+  <p:cSld>
+    <p:bg>
+      <p:bgPr>
+        <a:solidFill>
+          <a:srgbClr val="F7F9FC"/>
+        </a:solidFill>
+        <a:effectLst/>
+      </p:bgPr>
+    </p:bg>
+    <p:spTree>
+      <p:nvGrpSpPr>
+        <p:cNvPr id="1" name=""/>
+        <p:cNvGrpSpPr/>
+        <p:nvPr/>
+      </p:nvGrpSpPr>
+      <p:grpSpPr/>
+      <p:sp>
+        <p:nvSpPr>
+          <p:cNvPr id="2" name="Rectangle 1"/>
+          <p:cNvSpPr/>
+          <p:nvPr/>
+        </p:nvSpPr>
+        <p:spPr>
+          <a:xfrm>
+            <a:off x="0" y="0"/>
+            <a:ext cx="12191695" cy="914400"/>
+          </a:xfrm>
+          <a:prstGeom prst="rect">
+            <a:avLst/>
+          </a:prstGeom>
+          <a:solidFill>
+            <a:srgbClr val="111827"/>
+          </a:solidFill>
+          <a:ln>
+            <a:noFill/>
+          </a:ln>
+        </p:spPr>
+        <p:style>
+          <a:lnRef idx="1">
+            <a:schemeClr val="accent1"/>
+          </a:lnRef>
+          <a:fillRef idx="3">
+            <a:schemeClr val="accent1"/>
+          </a:fillRef>
+          <a:effectRef idx="2">
+            <a:schemeClr val="accent1"/>
+          </a:effectRef>
+          <a:fontRef idx="minor">
+            <a:schemeClr val="lt1"/>
+          </a:fontRef>
+        </p:style>
+        <p:txBody>
+          <a:bodyPr rtlCol="0" anchor="ctr"/>
+          <a:lstStyle/>
+          <a:p>
+            <a:pPr algn="ctr"/>
+          </a:p>
+        </p:txBody>
+      </p:sp>
+      <p:sp>
+        <p:nvSpPr>
+          <p:cNvPr id="3" name="TextBox 2"/>
+          <p:cNvSpPr txBox="1"/>
+          <p:nvPr/>
+        </p:nvSpPr>
+        <p:spPr>
+          <a:xfrm>
+            <a:off x="548640" y="182880"/>
+            <a:ext cx="8961120" cy="320040"/>
+          </a:xfrm>
+          <a:prstGeom prst="rect">
+            <a:avLst/>
+          </a:prstGeom>
+          <a:noFill/>
+        </p:spPr>
+        <p:txBody>
+          <a:bodyPr wrap="none">
+            <a:spAutoFit/>
+          </a:bodyPr>
+          <a:lstStyle/>
+          <a:p>
+            <a:r>
+              <a:rPr sz="2400" b="1">
+                <a:solidFill>
+                  <a:srgbClr val="FFFFFF"/>
+                </a:solidFill>
+              </a:rPr>
+              <a:t>Conclusion</a:t>
+            </a:r>
+          </a:p>
+        </p:txBody>
+      </p:sp>
+      <p:sp>
+        <p:nvSpPr>
+          <p:cNvPr id="4" name="TextBox 3"/>
+          <p:cNvSpPr txBox="1"/>
+          <p:nvPr/>
+        </p:nvSpPr>
+        <p:spPr>
+          <a:xfrm>
+            <a:off x="822960" y="1417320"/>
+            <a:ext cx="10332720" cy="3474720"/>
+          </a:xfrm>
+          <a:prstGeom prst="rect">
+            <a:avLst/>
+          </a:prstGeom>
+          <a:noFill/>
+        </p:spPr>
+        <p:txBody>
+          <a:bodyPr wrap="square">
+            <a:spAutoFit/>
+          </a:bodyPr>
+          <a:lstStyle/>
+          <a:p>
+            <a:pPr>
+              <a:spcAft>
+                <a:spcPts val="700"/>
+              </a:spcAft>
+              <a:defRPr sz="1900">
+                <a:solidFill>
+                  <a:srgbClr val="111827"/>
+                </a:solidFill>
+              </a:defRPr>
+            </a:pPr>
+            <a:r>
+              <a:t>Le projet repond au cahier des charges du cours.</a:t>
+            </a:r>
+          </a:p>
+          <a:p>
+            <a:pPr>
+              <a:spcAft>
+                <a:spcPts val="700"/>
+              </a:spcAft>
+              <a:defRPr sz="1900">
+                <a:solidFill>
+                  <a:srgbClr val="111827"/>
+                </a:solidFill>
+              </a:defRPr>
+            </a:pPr>
+            <a:r>
+              <a:t>Les deux roles sont bien distingues : client et administrateur.</a:t>
+            </a:r>
+          </a:p>
+          <a:p>
+            <a:pPr>
+              <a:spcAft>
+                <a:spcPts val="700"/>
+              </a:spcAft>
+              <a:defRPr sz="1900">
+                <a:solidFill>
+                  <a:srgbClr val="111827"/>
+                </a:solidFill>
+              </a:defRPr>
+            </a:pPr>
+            <a:r>
+              <a:t>Le catalogue, l'achat et la gestion admin fonctionnent.</a:t>
+            </a:r>
+          </a:p>
+          <a:p>
+            <a:pPr>
+              <a:spcAft>
+                <a:spcPts val="700"/>
+              </a:spcAft>
+              <a:defRPr sz="1900">
+                <a:solidFill>
+                  <a:srgbClr val="111827"/>
+                </a:solidFill>
+              </a:defRPr>
+            </a:pPr>
+            <a:r>
+              <a:t>Le stock est mis a jour automatiquement.</a:t>
+            </a:r>
+          </a:p>
+          <a:p>
+            <a:pPr>
+              <a:spcAft>
+                <a:spcPts val="700"/>
+              </a:spcAft>
+              <a:defRPr sz="1900">
+                <a:solidFill>
+                  <a:srgbClr val="111827"/>
+                </a:solidFill>
+              </a:defRPr>
+            </a:pPr>
+            <a:r>
+              <a:t>Le projet est documente et pret pour la soutenance.</a:t>
+            </a:r>
+          </a:p>
+        </p:txBody>
+      </p:sp>
+      <p:sp>
+        <p:nvSpPr>
+          <p:cNvPr id="5" name="TextBox 4"/>
+          <p:cNvSpPr txBox="1"/>
+          <p:nvPr/>
+        </p:nvSpPr>
+        <p:spPr>
+          <a:xfrm>
+            <a:off x="731520" y="5212080"/>
+            <a:ext cx="10698480" cy="548640"/>
+          </a:xfrm>
+          <a:prstGeom prst="rect">
+            <a:avLst/>
+          </a:prstGeom>
+          <a:noFill/>
+        </p:spPr>
+        <p:txBody>
+          <a:bodyPr wrap="none">
+            <a:spAutoFit/>
+          </a:bodyPr>
+          <a:lstStyle/>
+          <a:p>
+            <a:pPr algn="ctr"/>
+            <a:r>
+              <a:rPr sz="1800" b="1">
+                <a:solidFill>
+                  <a:srgbClr val="2563EB"/>
+                </a:solidFill>
+              </a:rPr>
+              <a:t>Comptes de demo : admin / admin123   |   client1 / client123</a:t>
             </a:r>
           </a:p>
         </p:txBody>
@@ -3248,7 +4526,7 @@
         <p:spPr>
           <a:xfrm>
             <a:off x="0" y="0"/>
-            <a:ext cx="12191695" cy="960120"/>
+            <a:ext cx="12191695" cy="914400"/>
           </a:xfrm>
           <a:prstGeom prst="rect">
             <a:avLst/>
@@ -3290,8 +4568,8 @@
         </p:nvSpPr>
         <p:spPr>
           <a:xfrm>
-            <a:off x="548640" y="201168"/>
-            <a:ext cx="7863840" cy="320040"/>
+            <a:off x="548640" y="182880"/>
+            <a:ext cx="8961120" cy="320040"/>
           </a:xfrm>
           <a:prstGeom prst="rect">
             <a:avLst/>
@@ -3305,12 +4583,12 @@
           <a:lstStyle/>
           <a:p>
             <a:r>
-              <a:rPr sz="2600" b="1">
+              <a:rPr sz="2400" b="1">
                 <a:solidFill>
                   <a:srgbClr val="FFFFFF"/>
                 </a:solidFill>
               </a:rPr>
-              <a:t>Objectif du projet</a:t>
+              <a:t>Plan de la presentation</a:t>
             </a:r>
           </a:p>
         </p:txBody>
@@ -3323,8 +4601,8 @@
         </p:nvSpPr>
         <p:spPr>
           <a:xfrm>
-            <a:off x="548640" y="566928"/>
-            <a:ext cx="8229600" cy="228600"/>
+            <a:off x="914400" y="1371600"/>
+            <a:ext cx="4754880" cy="4389120"/>
           </a:xfrm>
           <a:prstGeom prst="rect">
             <a:avLst/>
@@ -3332,18 +4610,128 @@
           <a:noFill/>
         </p:spPr>
         <p:txBody>
-          <a:bodyPr wrap="none">
+          <a:bodyPr wrap="square">
             <a:spAutoFit/>
           </a:bodyPr>
           <a:lstStyle/>
           <a:p>
-            <a:r>
-              <a:rPr sz="1100">
-                <a:solidFill>
-                  <a:srgbClr val="D1D5DB"/>
-                </a:solidFill>
-              </a:rPr>
-              <a:t>Un site de vente en ligne avec deux roles distincts</a:t>
+            <a:pPr>
+              <a:spcAft>
+                <a:spcPts val="700"/>
+              </a:spcAft>
+              <a:defRPr sz="2200">
+                <a:solidFill>
+                  <a:srgbClr val="111827"/>
+                </a:solidFill>
+              </a:defRPr>
+            </a:pPr>
+            <a:r>
+              <a:t>1. Objectif du projet</a:t>
+            </a:r>
+          </a:p>
+          <a:p>
+            <a:pPr>
+              <a:spcAft>
+                <a:spcPts val="700"/>
+              </a:spcAft>
+              <a:defRPr sz="2200">
+                <a:solidFill>
+                  <a:srgbClr val="111827"/>
+                </a:solidFill>
+              </a:defRPr>
+            </a:pPr>
+            <a:r>
+              <a:t>2. Fonctionnement du site</a:t>
+            </a:r>
+          </a:p>
+          <a:p>
+            <a:pPr>
+              <a:spcAft>
+                <a:spcPts val="700"/>
+              </a:spcAft>
+              <a:defRPr sz="2200">
+                <a:solidFill>
+                  <a:srgbClr val="111827"/>
+                </a:solidFill>
+              </a:defRPr>
+            </a:pPr>
+            <a:r>
+              <a:t>3. Structure du code</a:t>
+            </a:r>
+          </a:p>
+          <a:p>
+            <a:pPr>
+              <a:spcAft>
+                <a:spcPts val="700"/>
+              </a:spcAft>
+              <a:defRPr sz="2200">
+                <a:solidFill>
+                  <a:srgbClr val="111827"/>
+                </a:solidFill>
+              </a:defRPr>
+            </a:pPr>
+            <a:r>
+              <a:t>4. Repartition du travail</a:t>
+            </a:r>
+          </a:p>
+          <a:p>
+            <a:pPr>
+              <a:spcAft>
+                <a:spcPts val="700"/>
+              </a:spcAft>
+              <a:defRPr sz="2200">
+                <a:solidFill>
+                  <a:srgbClr val="111827"/>
+                </a:solidFill>
+              </a:defRPr>
+            </a:pPr>
+            <a:r>
+              <a:t>5. Choix de design</a:t>
+            </a:r>
+          </a:p>
+          <a:p>
+            <a:pPr>
+              <a:spcAft>
+                <a:spcPts val="700"/>
+              </a:spcAft>
+              <a:defRPr sz="2200">
+                <a:solidFill>
+                  <a:srgbClr val="111827"/>
+                </a:solidFill>
+              </a:defRPr>
+            </a:pPr>
+            <a:r>
+              <a:t>6. Demonstration</a:t>
+            </a:r>
+          </a:p>
+          <a:p>
+            <a:pPr>
+              <a:spcAft>
+                <a:spcPts val="700"/>
+              </a:spcAft>
+              <a:defRPr sz="2200">
+                <a:solidFill>
+                  <a:srgbClr val="111827"/>
+                </a:solidFill>
+              </a:defRPr>
+            </a:pPr>
+            <a:r>
+              <a:t>7. Difficultes rencontrees</a:t>
+            </a:r>
+          </a:p>
+          <a:p>
+            <a:pPr>
+              <a:spcAft>
+                <a:spcPts val="700"/>
+              </a:spcAft>
+              <a:defRPr sz="2200">
+                <a:solidFill>
+                  <a:srgbClr val="111827"/>
+                </a:solidFill>
+              </a:defRPr>
+            </a:pPr>
+            <a:r>
+              <a:t>8. Conclusion</a:t>
             </a:r>
           </a:p>
         </p:txBody>
@@ -3356,8 +4744,8 @@
         </p:nvSpPr>
         <p:spPr>
           <a:xfrm>
-            <a:off x="731520" y="1325880"/>
-            <a:ext cx="10789920" cy="4389120"/>
+            <a:off x="6035040" y="1828800"/>
+            <a:ext cx="4937760" cy="1645920"/>
           </a:xfrm>
           <a:prstGeom prst="rect">
             <a:avLst/>
@@ -3365,68 +4753,19 @@
           <a:noFill/>
         </p:spPr>
         <p:txBody>
-          <a:bodyPr wrap="square">
+          <a:bodyPr wrap="none">
             <a:spAutoFit/>
           </a:bodyPr>
           <a:lstStyle/>
           <a:p>
-            <a:pPr>
-              <a:spcAft>
-                <a:spcPts val="800"/>
-              </a:spcAft>
-              <a:defRPr sz="2000">
-                <a:solidFill>
-                  <a:srgbClr val="111827"/>
-                </a:solidFill>
-              </a:defRPr>
-            </a:pPr>
-            <a:r>
-              <a:t>Developper une boutique en ligne avec Django et SQLite.</a:t>
-            </a:r>
-          </a:p>
-          <a:p>
-            <a:pPr>
-              <a:spcAft>
-                <a:spcPts val="800"/>
-              </a:spcAft>
-              <a:defRPr sz="2000">
-                <a:solidFill>
-                  <a:srgbClr val="111827"/>
-                </a:solidFill>
-              </a:defRPr>
-            </a:pPr>
-            <a:r>
-              <a:t>Permettre la gestion des articles par un administrateur.</a:t>
-            </a:r>
-          </a:p>
-          <a:p>
-            <a:pPr>
-              <a:spcAft>
-                <a:spcPts val="800"/>
-              </a:spcAft>
-              <a:defRPr sz="2000">
-                <a:solidFill>
-                  <a:srgbClr val="111827"/>
-                </a:solidFill>
-              </a:defRPr>
-            </a:pPr>
-            <a:r>
-              <a:t>Permettre l'achat d'articles par un client connecte.</a:t>
-            </a:r>
-          </a:p>
-          <a:p>
-            <a:pPr>
-              <a:spcAft>
-                <a:spcPts val="800"/>
-              </a:spcAft>
-              <a:defRPr sz="2000">
-                <a:solidFill>
-                  <a:srgbClr val="111827"/>
-                </a:solidFill>
-              </a:defRPr>
-            </a:pPr>
-            <a:r>
-              <a:t>Mettre a jour automatiquement le stock apres achat.</a:t>
+            <a:pPr algn="l"/>
+            <a:r>
+              <a:rPr sz="1800">
+                <a:solidFill>
+                  <a:srgbClr val="4B5563"/>
+                </a:solidFill>
+              </a:rPr>
+              <a:t>La presentation doit surtout montrer que vous maitrisez l'objectif, la logique du site et votre repartition dans le groupe.</a:t>
             </a:r>
           </a:p>
         </p:txBody>
@@ -3466,7 +4805,7 @@
         <p:spPr>
           <a:xfrm>
             <a:off x="0" y="0"/>
-            <a:ext cx="12191695" cy="960120"/>
+            <a:ext cx="12191695" cy="914400"/>
           </a:xfrm>
           <a:prstGeom prst="rect">
             <a:avLst/>
@@ -3508,8 +4847,8 @@
         </p:nvSpPr>
         <p:spPr>
           <a:xfrm>
-            <a:off x="548640" y="201168"/>
-            <a:ext cx="7863840" cy="320040"/>
+            <a:off x="548640" y="182880"/>
+            <a:ext cx="8961120" cy="320040"/>
           </a:xfrm>
           <a:prstGeom prst="rect">
             <a:avLst/>
@@ -3523,12 +4862,12 @@
           <a:lstStyle/>
           <a:p>
             <a:r>
-              <a:rPr sz="2600" b="1">
+              <a:rPr sz="2400" b="1">
                 <a:solidFill>
                   <a:srgbClr val="FFFFFF"/>
                 </a:solidFill>
               </a:rPr>
-              <a:t>Fonctionnalites principales</a:t>
+              <a:t>Objectif et fonctionnement general</a:t>
             </a:r>
           </a:p>
         </p:txBody>
@@ -3541,8 +4880,8 @@
         </p:nvSpPr>
         <p:spPr>
           <a:xfrm>
-            <a:off x="731520" y="1325880"/>
-            <a:ext cx="5303520" cy="4389120"/>
+            <a:off x="822960" y="1371600"/>
+            <a:ext cx="10424160" cy="4389120"/>
           </a:xfrm>
           <a:prstGeom prst="rect">
             <a:avLst/>
@@ -3557,144 +4896,61 @@
           <a:p>
             <a:pPr>
               <a:spcAft>
-                <a:spcPts val="800"/>
+                <a:spcPts val="700"/>
               </a:spcAft>
-              <a:defRPr sz="2000">
+              <a:defRPr sz="1800">
                 <a:solidFill>
                   <a:srgbClr val="111827"/>
                 </a:solidFill>
               </a:defRPr>
             </a:pPr>
             <a:r>
-              <a:t>Catalogue : designation, image, stock, prix, categories.</a:t>
+              <a:t>Developper un site de vente en ligne avec Django et SQLite.</a:t>
             </a:r>
           </a:p>
           <a:p>
             <a:pPr>
               <a:spcAft>
-                <a:spcPts val="800"/>
+                <a:spcPts val="700"/>
               </a:spcAft>
-              <a:defRPr sz="2000">
+              <a:defRPr sz="1800">
                 <a:solidFill>
                   <a:srgbClr val="111827"/>
                 </a:solidFill>
               </a:defRPr>
             </a:pPr>
             <a:r>
-              <a:t>Client : connexion, inscription, achat avec quantite controlee.</a:t>
+              <a:t>Distinguer deux types d'utilisateurs : client et administrateur.</a:t>
             </a:r>
           </a:p>
           <a:p>
             <a:pPr>
               <a:spcAft>
-                <a:spcPts val="800"/>
+                <a:spcPts val="700"/>
               </a:spcAft>
-              <a:defRPr sz="2000">
+              <a:defRPr sz="1800">
                 <a:solidFill>
                   <a:srgbClr val="111827"/>
                 </a:solidFill>
               </a:defRPr>
             </a:pPr>
             <a:r>
-              <a:t>Administrateur : ajout, modification, suppression des articles.</a:t>
+              <a:t>Permettre la consultation du catalogue, la connexion et l'achat.</a:t>
             </a:r>
           </a:p>
           <a:p>
             <a:pPr>
               <a:spcAft>
-                <a:spcPts val="800"/>
+                <a:spcPts val="700"/>
               </a:spcAft>
-              <a:defRPr sz="2000">
+              <a:defRPr sz="1800">
                 <a:solidFill>
                   <a:srgbClr val="111827"/>
                 </a:solidFill>
               </a:defRPr>
             </a:pPr>
             <a:r>
-              <a:t>Base SQL SQLite et interface web Django.</a:t>
-            </a:r>
-          </a:p>
-        </p:txBody>
-      </p:sp>
-      <p:sp>
-        <p:nvSpPr>
-          <p:cNvPr id="5" name="TextBox 4"/>
-          <p:cNvSpPr txBox="1"/>
-          <p:nvPr/>
-        </p:nvSpPr>
-        <p:spPr>
-          <a:xfrm>
-            <a:off x="6126480" y="1325880"/>
-            <a:ext cx="5303520" cy="4389120"/>
-          </a:xfrm>
-          <a:prstGeom prst="rect">
-            <a:avLst/>
-          </a:prstGeom>
-          <a:noFill/>
-        </p:spPr>
-        <p:txBody>
-          <a:bodyPr wrap="square">
-            <a:spAutoFit/>
-          </a:bodyPr>
-          <a:lstStyle/>
-          <a:p>
-            <a:pPr>
-              <a:spcAft>
-                <a:spcPts val="800"/>
-              </a:spcAft>
-              <a:defRPr sz="2000">
-                <a:solidFill>
-                  <a:srgbClr val="111827"/>
-                </a:solidFill>
-              </a:defRPr>
-            </a:pPr>
-            <a:r>
-              <a:t>Images chargees depuis static/img.</a:t>
-            </a:r>
-          </a:p>
-          <a:p>
-            <a:pPr>
-              <a:spcAft>
-                <a:spcPts val="800"/>
-              </a:spcAft>
-              <a:defRPr sz="2000">
-                <a:solidFill>
-                  <a:srgbClr val="111827"/>
-                </a:solidFill>
-              </a:defRPr>
-            </a:pPr>
-            <a:r>
-              <a:t>Tests automatiques des parcours critiques.</a:t>
-            </a:r>
-          </a:p>
-          <a:p>
-            <a:pPr>
-              <a:spcAft>
-                <a:spcPts val="800"/>
-              </a:spcAft>
-              <a:defRPr sz="2000">
-                <a:solidFill>
-                  <a:srgbClr val="111827"/>
-                </a:solidFill>
-              </a:defRPr>
-            </a:pPr>
-            <a:r>
-              <a:t>Rapport PDF et captures de demonstration prepares.</a:t>
-            </a:r>
-          </a:p>
-          <a:p>
-            <a:pPr>
-              <a:spcAft>
-                <a:spcPts val="800"/>
-              </a:spcAft>
-              <a:defRPr sz="2000">
-                <a:solidFill>
-                  <a:srgbClr val="111827"/>
-                </a:solidFill>
-              </a:defRPr>
-            </a:pPr>
-            <a:r>
-              <a:t>Projet relancable depuis GitHub avec README.</a:t>
+              <a:t>Permettre la gestion des articles et la mise a jour du stock.</a:t>
             </a:r>
           </a:p>
         </p:txBody>
@@ -3734,7 +4990,7 @@
         <p:spPr>
           <a:xfrm>
             <a:off x="0" y="0"/>
-            <a:ext cx="12191695" cy="960120"/>
+            <a:ext cx="12191695" cy="914400"/>
           </a:xfrm>
           <a:prstGeom prst="rect">
             <a:avLst/>
@@ -3776,8 +5032,8 @@
         </p:nvSpPr>
         <p:spPr>
           <a:xfrm>
-            <a:off x="548640" y="201168"/>
-            <a:ext cx="7863840" cy="320040"/>
+            <a:off x="548640" y="182880"/>
+            <a:ext cx="8961120" cy="320040"/>
           </a:xfrm>
           <a:prstGeom prst="rect">
             <a:avLst/>
@@ -3791,95 +5047,26 @@
           <a:lstStyle/>
           <a:p>
             <a:r>
-              <a:rPr sz="2600" b="1">
+              <a:rPr sz="2400" b="1">
                 <a:solidFill>
                   <a:srgbClr val="FFFFFF"/>
                 </a:solidFill>
               </a:rPr>
-              <a:t>Demonstration client</a:t>
-            </a:r>
-          </a:p>
-        </p:txBody>
-      </p:sp>
-      <p:sp>
-        <p:nvSpPr>
-          <p:cNvPr id="4" name="Rounded Rectangle 3"/>
-          <p:cNvSpPr/>
-          <p:nvPr/>
-        </p:nvSpPr>
-        <p:spPr>
-          <a:xfrm>
-            <a:off x="594360" y="1325880"/>
-            <a:ext cx="3566160" cy="4709160"/>
-          </a:xfrm>
-          <a:prstGeom prst="roundRect">
-            <a:avLst/>
-          </a:prstGeom>
-          <a:solidFill>
-            <a:srgbClr val="FFFFFF"/>
-          </a:solidFill>
-          <a:ln>
-            <a:solidFill>
-              <a:srgbClr val="E2E8F0"/>
-            </a:solidFill>
-          </a:ln>
-        </p:spPr>
-        <p:style>
-          <a:lnRef idx="1">
-            <a:schemeClr val="accent1"/>
-          </a:lnRef>
-          <a:fillRef idx="3">
-            <a:schemeClr val="accent1"/>
-          </a:fillRef>
-          <a:effectRef idx="2">
-            <a:schemeClr val="accent1"/>
-          </a:effectRef>
-          <a:fontRef idx="minor">
-            <a:schemeClr val="lt1"/>
-          </a:fontRef>
-        </p:style>
-        <p:txBody>
-          <a:bodyPr rtlCol="0" anchor="ctr"/>
-          <a:lstStyle/>
-          <a:p>
-            <a:pPr algn="ctr"/>
-          </a:p>
-        </p:txBody>
-      </p:sp>
-      <p:pic>
-        <p:nvPicPr>
-          <p:cNvPr id="5" name="Picture 4" descr="01-login-page.png"/>
-          <p:cNvPicPr>
-            <a:picLocks noChangeAspect="1"/>
-          </p:cNvPicPr>
-          <p:nvPr/>
-        </p:nvPicPr>
-        <p:blipFill>
-          <a:blip r:embed="rId2"/>
-          <a:stretch>
-            <a:fillRect/>
-          </a:stretch>
-        </p:blipFill>
-        <p:spPr>
-          <a:xfrm>
-            <a:off x="704088" y="1435608"/>
-            <a:ext cx="3346704" cy="4297680"/>
-          </a:xfrm>
-          <a:prstGeom prst="rect">
-            <a:avLst/>
-          </a:prstGeom>
-        </p:spPr>
-      </p:pic>
-      <p:sp>
-        <p:nvSpPr>
-          <p:cNvPr id="6" name="TextBox 5"/>
+              <a:t>Ce que le site permet de faire</a:t>
+            </a:r>
+          </a:p>
+        </p:txBody>
+      </p:sp>
+      <p:sp>
+        <p:nvSpPr>
+          <p:cNvPr id="4" name="TextBox 3"/>
           <p:cNvSpPr txBox="1"/>
           <p:nvPr/>
         </p:nvSpPr>
         <p:spPr>
           <a:xfrm>
-            <a:off x="594360" y="5779008"/>
-            <a:ext cx="3566160" cy="320040"/>
+            <a:off x="822960" y="1371600"/>
+            <a:ext cx="5120640" cy="4389120"/>
           </a:xfrm>
           <a:prstGeom prst="rect">
             <a:avLst/>
@@ -3887,102 +5074,82 @@
           <a:noFill/>
         </p:spPr>
         <p:txBody>
-          <a:bodyPr wrap="none">
+          <a:bodyPr wrap="square">
             <a:spAutoFit/>
           </a:bodyPr>
           <a:lstStyle/>
           <a:p>
-            <a:pPr algn="ctr"/>
-            <a:r>
-              <a:rPr sz="1200">
-                <a:solidFill>
-                  <a:srgbClr val="4B5563"/>
-                </a:solidFill>
-              </a:rPr>
-              <a:t>Connexion</a:t>
-            </a:r>
-          </a:p>
-        </p:txBody>
-      </p:sp>
-      <p:sp>
-        <p:nvSpPr>
-          <p:cNvPr id="7" name="Rounded Rectangle 6"/>
-          <p:cNvSpPr/>
-          <p:nvPr/>
-        </p:nvSpPr>
-        <p:spPr>
-          <a:xfrm>
-            <a:off x="4315968" y="1325880"/>
-            <a:ext cx="3703320" cy="4709160"/>
-          </a:xfrm>
-          <a:prstGeom prst="roundRect">
-            <a:avLst/>
-          </a:prstGeom>
-          <a:solidFill>
-            <a:srgbClr val="FFFFFF"/>
-          </a:solidFill>
-          <a:ln>
-            <a:solidFill>
-              <a:srgbClr val="E2E8F0"/>
-            </a:solidFill>
-          </a:ln>
-        </p:spPr>
-        <p:style>
-          <a:lnRef idx="1">
-            <a:schemeClr val="accent1"/>
-          </a:lnRef>
-          <a:fillRef idx="3">
-            <a:schemeClr val="accent1"/>
-          </a:fillRef>
-          <a:effectRef idx="2">
-            <a:schemeClr val="accent1"/>
-          </a:effectRef>
-          <a:fontRef idx="minor">
-            <a:schemeClr val="lt1"/>
-          </a:fontRef>
-        </p:style>
-        <p:txBody>
-          <a:bodyPr rtlCol="0" anchor="ctr"/>
-          <a:lstStyle/>
-          <a:p>
-            <a:pPr algn="ctr"/>
-          </a:p>
-        </p:txBody>
-      </p:sp>
-      <p:pic>
-        <p:nvPicPr>
-          <p:cNvPr id="8" name="Picture 7" descr="02-catalogue-client.png"/>
-          <p:cNvPicPr>
-            <a:picLocks noChangeAspect="1"/>
-          </p:cNvPicPr>
-          <p:nvPr/>
-        </p:nvPicPr>
-        <p:blipFill>
-          <a:blip r:embed="rId3"/>
-          <a:stretch>
-            <a:fillRect/>
-          </a:stretch>
-        </p:blipFill>
-        <p:spPr>
-          <a:xfrm>
-            <a:off x="4425696" y="1435608"/>
-            <a:ext cx="3483864" cy="4297680"/>
-          </a:xfrm>
-          <a:prstGeom prst="rect">
-            <a:avLst/>
-          </a:prstGeom>
-        </p:spPr>
-      </p:pic>
-      <p:sp>
-        <p:nvSpPr>
-          <p:cNvPr id="9" name="TextBox 8"/>
+            <a:pPr>
+              <a:spcAft>
+                <a:spcPts val="700"/>
+              </a:spcAft>
+              <a:defRPr sz="1800">
+                <a:solidFill>
+                  <a:srgbClr val="111827"/>
+                </a:solidFill>
+              </a:defRPr>
+            </a:pPr>
+            <a:r>
+              <a:t>Client : voir les articles, les images, le stock et le prix.</a:t>
+            </a:r>
+          </a:p>
+          <a:p>
+            <a:pPr>
+              <a:spcAft>
+                <a:spcPts val="700"/>
+              </a:spcAft>
+              <a:defRPr sz="1800">
+                <a:solidFill>
+                  <a:srgbClr val="111827"/>
+                </a:solidFill>
+              </a:defRPr>
+            </a:pPr>
+            <a:r>
+              <a:t>Client : se connecter, s'inscrire et acheter une quantite disponible.</a:t>
+            </a:r>
+          </a:p>
+          <a:p>
+            <a:pPr>
+              <a:spcAft>
+                <a:spcPts val="700"/>
+              </a:spcAft>
+              <a:defRPr sz="1800">
+                <a:solidFill>
+                  <a:srgbClr val="111827"/>
+                </a:solidFill>
+              </a:defRPr>
+            </a:pPr>
+            <a:r>
+              <a:t>Administrateur : ajouter, modifier et supprimer des articles.</a:t>
+            </a:r>
+          </a:p>
+          <a:p>
+            <a:pPr>
+              <a:spcAft>
+                <a:spcPts val="700"/>
+              </a:spcAft>
+              <a:defRPr sz="1800">
+                <a:solidFill>
+                  <a:srgbClr val="111827"/>
+                </a:solidFill>
+              </a:defRPr>
+            </a:pPr>
+            <a:r>
+              <a:t>Le stock diminue automatiquement apres un achat valide.</a:t>
+            </a:r>
+          </a:p>
+        </p:txBody>
+      </p:sp>
+      <p:sp>
+        <p:nvSpPr>
+          <p:cNvPr id="5" name="TextBox 4"/>
           <p:cNvSpPr txBox="1"/>
           <p:nvPr/>
         </p:nvSpPr>
         <p:spPr>
           <a:xfrm>
-            <a:off x="4315968" y="5779008"/>
-            <a:ext cx="3703320" cy="320040"/>
+            <a:off x="5943600" y="1371600"/>
+            <a:ext cx="5212080" cy="4389120"/>
           </a:xfrm>
           <a:prstGeom prst="rect">
             <a:avLst/>
@@ -3990,122 +5157,68 @@
           <a:noFill/>
         </p:spPr>
         <p:txBody>
-          <a:bodyPr wrap="none">
+          <a:bodyPr wrap="square">
             <a:spAutoFit/>
           </a:bodyPr>
           <a:lstStyle/>
           <a:p>
-            <a:pPr algn="ctr"/>
-            <a:r>
-              <a:rPr sz="1200">
-                <a:solidFill>
-                  <a:srgbClr val="4B5563"/>
-                </a:solidFill>
-              </a:rPr>
-              <a:t>Catalogue</a:t>
-            </a:r>
-          </a:p>
-        </p:txBody>
-      </p:sp>
-      <p:sp>
-        <p:nvSpPr>
-          <p:cNvPr id="10" name="Rounded Rectangle 9"/>
-          <p:cNvSpPr/>
-          <p:nvPr/>
-        </p:nvSpPr>
-        <p:spPr>
-          <a:xfrm>
-            <a:off x="8174736" y="1325880"/>
-            <a:ext cx="3429000" cy="4709160"/>
-          </a:xfrm>
-          <a:prstGeom prst="roundRect">
-            <a:avLst/>
-          </a:prstGeom>
-          <a:solidFill>
-            <a:srgbClr val="FFFFFF"/>
-          </a:solidFill>
-          <a:ln>
-            <a:solidFill>
-              <a:srgbClr val="E2E8F0"/>
-            </a:solidFill>
-          </a:ln>
-        </p:spPr>
-        <p:style>
-          <a:lnRef idx="1">
-            <a:schemeClr val="accent1"/>
-          </a:lnRef>
-          <a:fillRef idx="3">
-            <a:schemeClr val="accent1"/>
-          </a:fillRef>
-          <a:effectRef idx="2">
-            <a:schemeClr val="accent1"/>
-          </a:effectRef>
-          <a:fontRef idx="minor">
-            <a:schemeClr val="lt1"/>
-          </a:fontRef>
-        </p:style>
-        <p:txBody>
-          <a:bodyPr rtlCol="0" anchor="ctr"/>
-          <a:lstStyle/>
-          <a:p>
-            <a:pPr algn="ctr"/>
-          </a:p>
-        </p:txBody>
-      </p:sp>
-      <p:pic>
-        <p:nvPicPr>
-          <p:cNvPr id="11" name="Picture 10" descr="03-achat-page.png"/>
-          <p:cNvPicPr>
-            <a:picLocks noChangeAspect="1"/>
-          </p:cNvPicPr>
-          <p:nvPr/>
-        </p:nvPicPr>
-        <p:blipFill>
-          <a:blip r:embed="rId4"/>
-          <a:stretch>
-            <a:fillRect/>
-          </a:stretch>
-        </p:blipFill>
-        <p:spPr>
-          <a:xfrm>
-            <a:off x="8284464" y="1435608"/>
-            <a:ext cx="3209544" cy="4297680"/>
-          </a:xfrm>
-          <a:prstGeom prst="rect">
-            <a:avLst/>
-          </a:prstGeom>
-        </p:spPr>
-      </p:pic>
-      <p:sp>
-        <p:nvSpPr>
-          <p:cNvPr id="12" name="TextBox 11"/>
-          <p:cNvSpPr txBox="1"/>
-          <p:nvPr/>
-        </p:nvSpPr>
-        <p:spPr>
-          <a:xfrm>
-            <a:off x="8174736" y="5779008"/>
-            <a:ext cx="3429000" cy="320040"/>
-          </a:xfrm>
-          <a:prstGeom prst="rect">
-            <a:avLst/>
-          </a:prstGeom>
-          <a:noFill/>
-        </p:spPr>
-        <p:txBody>
-          <a:bodyPr wrap="none">
-            <a:spAutoFit/>
-          </a:bodyPr>
-          <a:lstStyle/>
-          <a:p>
-            <a:pPr algn="ctr"/>
-            <a:r>
-              <a:rPr sz="1200">
-                <a:solidFill>
-                  <a:srgbClr val="4B5563"/>
-                </a:solidFill>
-              </a:rPr>
-              <a:t>Achat</a:t>
+            <a:pPr>
+              <a:spcAft>
+                <a:spcPts val="700"/>
+              </a:spcAft>
+              <a:defRPr sz="1800">
+                <a:solidFill>
+                  <a:srgbClr val="111827"/>
+                </a:solidFill>
+              </a:defRPr>
+            </a:pPr>
+            <a:r>
+              <a:t>Les categories facilitent la navigation.</a:t>
+            </a:r>
+          </a:p>
+          <a:p>
+            <a:pPr>
+              <a:spcAft>
+                <a:spcPts val="700"/>
+              </a:spcAft>
+              <a:defRPr sz="1800">
+                <a:solidFill>
+                  <a:srgbClr val="111827"/>
+                </a:solidFill>
+              </a:defRPr>
+            </a:pPr>
+            <a:r>
+              <a:t>Le catalogue s'appuie sur les donnees de la base SQLite.</a:t>
+            </a:r>
+          </a:p>
+          <a:p>
+            <a:pPr>
+              <a:spcAft>
+                <a:spcPts val="700"/>
+              </a:spcAft>
+              <a:defRPr sz="1800">
+                <a:solidFill>
+                  <a:srgbClr val="111827"/>
+                </a:solidFill>
+              </a:defRPr>
+            </a:pPr>
+            <a:r>
+              <a:t>Les images sont chargees depuis static/img.</a:t>
+            </a:r>
+          </a:p>
+          <a:p>
+            <a:pPr>
+              <a:spcAft>
+                <a:spcPts val="700"/>
+              </a:spcAft>
+              <a:defRPr sz="1800">
+                <a:solidFill>
+                  <a:srgbClr val="111827"/>
+                </a:solidFill>
+              </a:defRPr>
+            </a:pPr>
+            <a:r>
+              <a:t>Les messages de succes et d'erreur guident l'utilisateur.</a:t>
             </a:r>
           </a:p>
         </p:txBody>
@@ -4145,7 +5258,7 @@
         <p:spPr>
           <a:xfrm>
             <a:off x="0" y="0"/>
-            <a:ext cx="12191695" cy="960120"/>
+            <a:ext cx="12191695" cy="914400"/>
           </a:xfrm>
           <a:prstGeom prst="rect">
             <a:avLst/>
@@ -4187,8 +5300,8 @@
         </p:nvSpPr>
         <p:spPr>
           <a:xfrm>
-            <a:off x="548640" y="201168"/>
-            <a:ext cx="7863840" cy="320040"/>
+            <a:off x="548640" y="182880"/>
+            <a:ext cx="8961120" cy="320040"/>
           </a:xfrm>
           <a:prstGeom prst="rect">
             <a:avLst/>
@@ -4202,95 +5315,26 @@
           <a:lstStyle/>
           <a:p>
             <a:r>
-              <a:rPr sz="2600" b="1">
+              <a:rPr sz="2400" b="1">
                 <a:solidFill>
                   <a:srgbClr val="FFFFFF"/>
                 </a:solidFill>
               </a:rPr>
-              <a:t>Verification du stock et gestion admin</a:t>
-            </a:r>
-          </a:p>
-        </p:txBody>
-      </p:sp>
-      <p:sp>
-        <p:nvSpPr>
-          <p:cNvPr id="4" name="Rounded Rectangle 3"/>
-          <p:cNvSpPr/>
-          <p:nvPr/>
-        </p:nvSpPr>
-        <p:spPr>
-          <a:xfrm>
-            <a:off x="685800" y="1417320"/>
-            <a:ext cx="5394960" cy="4526280"/>
-          </a:xfrm>
-          <a:prstGeom prst="roundRect">
-            <a:avLst/>
-          </a:prstGeom>
-          <a:solidFill>
-            <a:srgbClr val="FFFFFF"/>
-          </a:solidFill>
-          <a:ln>
-            <a:solidFill>
-              <a:srgbClr val="E2E8F0"/>
-            </a:solidFill>
-          </a:ln>
-        </p:spPr>
-        <p:style>
-          <a:lnRef idx="1">
-            <a:schemeClr val="accent1"/>
-          </a:lnRef>
-          <a:fillRef idx="3">
-            <a:schemeClr val="accent1"/>
-          </a:fillRef>
-          <a:effectRef idx="2">
-            <a:schemeClr val="accent1"/>
-          </a:effectRef>
-          <a:fontRef idx="minor">
-            <a:schemeClr val="lt1"/>
-          </a:fontRef>
-        </p:style>
-        <p:txBody>
-          <a:bodyPr rtlCol="0" anchor="ctr"/>
-          <a:lstStyle/>
-          <a:p>
-            <a:pPr algn="ctr"/>
-          </a:p>
-        </p:txBody>
-      </p:sp>
-      <p:pic>
-        <p:nvPicPr>
-          <p:cNvPr id="5" name="Picture 4" descr="04-stock-apres-achat.png"/>
-          <p:cNvPicPr>
-            <a:picLocks noChangeAspect="1"/>
-          </p:cNvPicPr>
-          <p:nvPr/>
-        </p:nvPicPr>
-        <p:blipFill>
-          <a:blip r:embed="rId2"/>
-          <a:stretch>
-            <a:fillRect/>
-          </a:stretch>
-        </p:blipFill>
-        <p:spPr>
-          <a:xfrm>
-            <a:off x="795528" y="1527048"/>
-            <a:ext cx="5175504" cy="4114800"/>
-          </a:xfrm>
-          <a:prstGeom prst="rect">
-            <a:avLst/>
-          </a:prstGeom>
-        </p:spPr>
-      </p:pic>
-      <p:sp>
-        <p:nvSpPr>
-          <p:cNvPr id="6" name="TextBox 5"/>
+              <a:t>Structure du code</a:t>
+            </a:r>
+          </a:p>
+        </p:txBody>
+      </p:sp>
+      <p:sp>
+        <p:nvSpPr>
+          <p:cNvPr id="4" name="TextBox 3"/>
           <p:cNvSpPr txBox="1"/>
           <p:nvPr/>
         </p:nvSpPr>
         <p:spPr>
           <a:xfrm>
-            <a:off x="685800" y="5687568"/>
-            <a:ext cx="5394960" cy="320040"/>
+            <a:off x="822960" y="1325880"/>
+            <a:ext cx="5303520" cy="4480560"/>
           </a:xfrm>
           <a:prstGeom prst="rect">
             <a:avLst/>
@@ -4298,102 +5342,112 @@
           <a:noFill/>
         </p:spPr>
         <p:txBody>
-          <a:bodyPr wrap="none">
+          <a:bodyPr wrap="square">
             <a:spAutoFit/>
           </a:bodyPr>
           <a:lstStyle/>
           <a:p>
-            <a:pPr algn="ctr"/>
-            <a:r>
-              <a:rPr sz="1200">
-                <a:solidFill>
-                  <a:srgbClr val="4B5563"/>
-                </a:solidFill>
-              </a:rPr>
-              <a:t>Stock apres achat</a:t>
-            </a:r>
-          </a:p>
-        </p:txBody>
-      </p:sp>
-      <p:sp>
-        <p:nvSpPr>
-          <p:cNvPr id="7" name="Rounded Rectangle 6"/>
-          <p:cNvSpPr/>
-          <p:nvPr/>
-        </p:nvSpPr>
-        <p:spPr>
-          <a:xfrm>
-            <a:off x="6172200" y="1417320"/>
-            <a:ext cx="5394960" cy="4526280"/>
-          </a:xfrm>
-          <a:prstGeom prst="roundRect">
-            <a:avLst/>
-          </a:prstGeom>
-          <a:solidFill>
-            <a:srgbClr val="FFFFFF"/>
-          </a:solidFill>
-          <a:ln>
-            <a:solidFill>
-              <a:srgbClr val="E2E8F0"/>
-            </a:solidFill>
-          </a:ln>
-        </p:spPr>
-        <p:style>
-          <a:lnRef idx="1">
-            <a:schemeClr val="accent1"/>
-          </a:lnRef>
-          <a:fillRef idx="3">
-            <a:schemeClr val="accent1"/>
-          </a:fillRef>
-          <a:effectRef idx="2">
-            <a:schemeClr val="accent1"/>
-          </a:effectRef>
-          <a:fontRef idx="minor">
-            <a:schemeClr val="lt1"/>
-          </a:fontRef>
-        </p:style>
-        <p:txBody>
-          <a:bodyPr rtlCol="0" anchor="ctr"/>
-          <a:lstStyle/>
-          <a:p>
-            <a:pPr algn="ctr"/>
-          </a:p>
-        </p:txBody>
-      </p:sp>
-      <p:pic>
-        <p:nvPicPr>
-          <p:cNvPr id="8" name="Picture 7" descr="05-gestion-admin.png"/>
-          <p:cNvPicPr>
-            <a:picLocks noChangeAspect="1"/>
-          </p:cNvPicPr>
-          <p:nvPr/>
-        </p:nvPicPr>
-        <p:blipFill>
-          <a:blip r:embed="rId3"/>
-          <a:stretch>
-            <a:fillRect/>
-          </a:stretch>
-        </p:blipFill>
-        <p:spPr>
-          <a:xfrm>
-            <a:off x="6281928" y="1527048"/>
-            <a:ext cx="5175504" cy="4114800"/>
-          </a:xfrm>
-          <a:prstGeom prst="rect">
-            <a:avLst/>
-          </a:prstGeom>
-        </p:spPr>
-      </p:pic>
-      <p:sp>
-        <p:nvSpPr>
-          <p:cNvPr id="9" name="TextBox 8"/>
+            <a:pPr>
+              <a:spcAft>
+                <a:spcPts val="700"/>
+              </a:spcAft>
+              <a:defRPr sz="1800">
+                <a:solidFill>
+                  <a:srgbClr val="111827"/>
+                </a:solidFill>
+              </a:defRPr>
+            </a:pPr>
+            <a:r>
+              <a:t>boutique_vetements/ : configuration generale Django</a:t>
+            </a:r>
+          </a:p>
+          <a:p>
+            <a:pPr>
+              <a:spcAft>
+                <a:spcPts val="700"/>
+              </a:spcAft>
+              <a:defRPr sz="1800">
+                <a:solidFill>
+                  <a:srgbClr val="111827"/>
+                </a:solidFill>
+              </a:defRPr>
+            </a:pPr>
+            <a:r>
+              <a:t>shop/ : application principale du projet</a:t>
+            </a:r>
+          </a:p>
+          <a:p>
+            <a:pPr>
+              <a:spcAft>
+                <a:spcPts val="700"/>
+              </a:spcAft>
+              <a:defRPr sz="1800">
+                <a:solidFill>
+                  <a:srgbClr val="111827"/>
+                </a:solidFill>
+              </a:defRPr>
+            </a:pPr>
+            <a:r>
+              <a:t>templates/ : pages HTML du site</a:t>
+            </a:r>
+          </a:p>
+          <a:p>
+            <a:pPr>
+              <a:spcAft>
+                <a:spcPts val="700"/>
+              </a:spcAft>
+              <a:defRPr sz="1800">
+                <a:solidFill>
+                  <a:srgbClr val="111827"/>
+                </a:solidFill>
+              </a:defRPr>
+            </a:pPr>
+            <a:r>
+              <a:t>static/ : images, CSS et JavaScript</a:t>
+            </a:r>
+          </a:p>
+          <a:p>
+            <a:pPr>
+              <a:spcAft>
+                <a:spcPts val="700"/>
+              </a:spcAft>
+              <a:defRPr sz="1800">
+                <a:solidFill>
+                  <a:srgbClr val="111827"/>
+                </a:solidFill>
+              </a:defRPr>
+            </a:pPr>
+            <a:r>
+              <a:t>docs/ : captures, PDF et presentation</a:t>
+            </a:r>
+          </a:p>
+          <a:p>
+            <a:pPr>
+              <a:spcAft>
+                <a:spcPts val="700"/>
+              </a:spcAft>
+              <a:defRPr sz="1800">
+                <a:solidFill>
+                  <a:srgbClr val="111827"/>
+                </a:solidFill>
+              </a:defRPr>
+            </a:pPr>
+            <a:r>
+              <a:t>scripts/ : automatisation de captures et presentation</a:t>
+            </a:r>
+          </a:p>
+        </p:txBody>
+      </p:sp>
+      <p:sp>
+        <p:nvSpPr>
+          <p:cNvPr id="5" name="TextBox 4"/>
           <p:cNvSpPr txBox="1"/>
           <p:nvPr/>
         </p:nvSpPr>
         <p:spPr>
           <a:xfrm>
-            <a:off x="6172200" y="5687568"/>
-            <a:ext cx="5394960" cy="320040"/>
+            <a:off x="6080760" y="1325880"/>
+            <a:ext cx="5120640" cy="4480560"/>
           </a:xfrm>
           <a:prstGeom prst="rect">
             <a:avLst/>
@@ -4401,19 +5455,98 @@
           <a:noFill/>
         </p:spPr>
         <p:txBody>
-          <a:bodyPr wrap="none">
+          <a:bodyPr wrap="square">
             <a:spAutoFit/>
           </a:bodyPr>
           <a:lstStyle/>
           <a:p>
-            <a:pPr algn="ctr"/>
-            <a:r>
-              <a:rPr sz="1200">
-                <a:solidFill>
-                  <a:srgbClr val="4B5563"/>
-                </a:solidFill>
-              </a:rPr>
-              <a:t>Gestion administrateur</a:t>
+            <a:pPr>
+              <a:spcAft>
+                <a:spcPts val="700"/>
+              </a:spcAft>
+              <a:defRPr sz="1800">
+                <a:solidFill>
+                  <a:srgbClr val="111827"/>
+                </a:solidFill>
+              </a:defRPr>
+            </a:pPr>
+            <a:r>
+              <a:t>shop/models.py : modele Article</a:t>
+            </a:r>
+          </a:p>
+          <a:p>
+            <a:pPr>
+              <a:spcAft>
+                <a:spcPts val="700"/>
+              </a:spcAft>
+              <a:defRPr sz="1800">
+                <a:solidFill>
+                  <a:srgbClr val="111827"/>
+                </a:solidFill>
+              </a:defRPr>
+            </a:pPr>
+            <a:r>
+              <a:t>shop/views.py : logique metier</a:t>
+            </a:r>
+          </a:p>
+          <a:p>
+            <a:pPr>
+              <a:spcAft>
+                <a:spcPts val="700"/>
+              </a:spcAft>
+              <a:defRPr sz="1800">
+                <a:solidFill>
+                  <a:srgbClr val="111827"/>
+                </a:solidFill>
+              </a:defRPr>
+            </a:pPr>
+            <a:r>
+              <a:t>shop/forms.py : formulaires</a:t>
+            </a:r>
+          </a:p>
+          <a:p>
+            <a:pPr>
+              <a:spcAft>
+                <a:spcPts val="700"/>
+              </a:spcAft>
+              <a:defRPr sz="1800">
+                <a:solidFill>
+                  <a:srgbClr val="111827"/>
+                </a:solidFill>
+              </a:defRPr>
+            </a:pPr>
+            <a:r>
+              <a:t>shop/urls.py : routes du site</a:t>
+            </a:r>
+          </a:p>
+          <a:p>
+            <a:pPr>
+              <a:spcAft>
+                <a:spcPts val="700"/>
+              </a:spcAft>
+              <a:defRPr sz="1800">
+                <a:solidFill>
+                  <a:srgbClr val="111827"/>
+                </a:solidFill>
+              </a:defRPr>
+            </a:pPr>
+            <a:r>
+              <a:t>shop/tests.py : tests automatiques</a:t>
+            </a:r>
+          </a:p>
+          <a:p>
+            <a:pPr>
+              <a:spcAft>
+                <a:spcPts val="700"/>
+              </a:spcAft>
+              <a:defRPr sz="1800">
+                <a:solidFill>
+                  <a:srgbClr val="111827"/>
+                </a:solidFill>
+              </a:defRPr>
+            </a:pPr>
+            <a:r>
+              <a:t>init_data.py : donnees de demonstration</a:t>
             </a:r>
           </a:p>
         </p:txBody>
@@ -4453,7 +5586,7 @@
         <p:spPr>
           <a:xfrm>
             <a:off x="0" y="0"/>
-            <a:ext cx="12191695" cy="960120"/>
+            <a:ext cx="12191695" cy="914400"/>
           </a:xfrm>
           <a:prstGeom prst="rect">
             <a:avLst/>
@@ -4495,8 +5628,8 @@
         </p:nvSpPr>
         <p:spPr>
           <a:xfrm>
-            <a:off x="548640" y="201168"/>
-            <a:ext cx="7863840" cy="320040"/>
+            <a:off x="548640" y="182880"/>
+            <a:ext cx="8961120" cy="320040"/>
           </a:xfrm>
           <a:prstGeom prst="rect">
             <a:avLst/>
@@ -4510,306 +5643,129 @@
           <a:lstStyle/>
           <a:p>
             <a:r>
-              <a:rPr sz="2600" b="1">
+              <a:rPr sz="2400" b="1">
                 <a:solidFill>
                   <a:srgbClr val="FFFFFF"/>
                 </a:solidFill>
               </a:rPr>
-              <a:t>Repartition du travail</a:t>
-            </a:r>
-          </a:p>
-        </p:txBody>
-      </p:sp>
-      <p:graphicFrame>
-        <p:nvGraphicFramePr>
-          <p:cNvPr id="4" name="Table 3"/>
-          <p:cNvGraphicFramePr>
-            <a:graphicFrameLocks noGrp="1"/>
-          </p:cNvGraphicFramePr>
+              <a:t>Quel code fait quoi ?</a:t>
+            </a:r>
+          </a:p>
+        </p:txBody>
+      </p:sp>
+      <p:sp>
+        <p:nvSpPr>
+          <p:cNvPr id="4" name="TextBox 3"/>
+          <p:cNvSpPr txBox="1"/>
           <p:nvPr/>
-        </p:nvGraphicFramePr>
-        <p:xfrm>
-          <a:off x="777240" y="1463040"/>
-          <a:ext cx="10698480" cy="4206240"/>
-        </p:xfrm>
-        <a:graphic>
-          <a:graphicData uri="http://schemas.openxmlformats.org/drawingml/2006/table">
-            <a:tbl>
-              <a:tblPr firstRow="1" bandRow="1">
-                <a:tableStyleId>{5C22544A-7EE6-4342-B048-85BDC9FD1C3A}</a:tableStyleId>
-              </a:tblPr>
-              <a:tblGrid>
-                <a:gridCol w="2011680"/>
-                <a:gridCol w="8686800"/>
-              </a:tblGrid>
-              <a:tr h="701040">
-                <a:tc>
-                  <a:txBody>
-                    <a:bodyPr/>
-                    <a:lstStyle/>
-                    <a:p>
-                      <a:r>
-                        <a:rPr b="1" sz="1400">
-                          <a:solidFill>
-                            <a:srgbClr val="FFFFFF"/>
-                          </a:solidFill>
-                        </a:rPr>
-                        <a:t>Membre</a:t>
-                      </a:r>
-                    </a:p>
-                  </a:txBody>
-                  <a:tcPr>
-                    <a:solidFill>
-                      <a:srgbClr val="111827"/>
-                    </a:solidFill>
-                  </a:tcPr>
-                </a:tc>
-                <a:tc>
-                  <a:txBody>
-                    <a:bodyPr/>
-                    <a:lstStyle/>
-                    <a:p>
-                      <a:r>
-                        <a:rPr b="1" sz="1400">
-                          <a:solidFill>
-                            <a:srgbClr val="FFFFFF"/>
-                          </a:solidFill>
-                        </a:rPr>
-                        <a:t>Contribution</a:t>
-                      </a:r>
-                    </a:p>
-                  </a:txBody>
-                  <a:tcPr>
-                    <a:solidFill>
-                      <a:srgbClr val="111827"/>
-                    </a:solidFill>
-                  </a:tcPr>
-                </a:tc>
-              </a:tr>
-              <a:tr h="701040">
-                <a:tc>
-                  <a:txBody>
-                    <a:bodyPr/>
-                    <a:lstStyle/>
-                    <a:p>
-                      <a:r>
-                        <a:rPr sz="1300">
-                          <a:solidFill>
-                            <a:srgbClr val="111827"/>
-                          </a:solidFill>
-                        </a:rPr>
-                        <a:t>Zeinabou</a:t>
-                      </a:r>
-                    </a:p>
-                  </a:txBody>
-                  <a:tcPr>
-                    <a:solidFill>
-                      <a:srgbClr val="FFFFFF"/>
-                    </a:solidFill>
-                  </a:tcPr>
-                </a:tc>
-                <a:tc>
-                  <a:txBody>
-                    <a:bodyPr/>
-                    <a:lstStyle/>
-                    <a:p>
-                      <a:r>
-                        <a:rPr sz="1300">
-                          <a:solidFill>
-                            <a:srgbClr val="111827"/>
-                          </a:solidFill>
-                        </a:rPr>
-                        <a:t>Structure du projet, URLs, integration finale et verification.</a:t>
-                      </a:r>
-                    </a:p>
-                  </a:txBody>
-                  <a:tcPr>
-                    <a:solidFill>
-                      <a:srgbClr val="FFFFFF"/>
-                    </a:solidFill>
-                  </a:tcPr>
-                </a:tc>
-              </a:tr>
-              <a:tr h="701040">
-                <a:tc>
-                  <a:txBody>
-                    <a:bodyPr/>
-                    <a:lstStyle/>
-                    <a:p>
-                      <a:r>
-                        <a:rPr sz="1300">
-                          <a:solidFill>
-                            <a:srgbClr val="111827"/>
-                          </a:solidFill>
-                        </a:rPr>
-                        <a:t>Assia</a:t>
-                      </a:r>
-                    </a:p>
-                  </a:txBody>
-                  <a:tcPr>
-                    <a:solidFill>
-                      <a:srgbClr val="FFFFFF"/>
-                    </a:solidFill>
-                  </a:tcPr>
-                </a:tc>
-                <a:tc>
-                  <a:txBody>
-                    <a:bodyPr/>
-                    <a:lstStyle/>
-                    <a:p>
-                      <a:r>
-                        <a:rPr sz="1300">
-                          <a:solidFill>
-                            <a:srgbClr val="111827"/>
-                          </a:solidFill>
-                        </a:rPr>
-                        <a:t>Modele Article, base SQLite, categories, admin.</a:t>
-                      </a:r>
-                    </a:p>
-                  </a:txBody>
-                  <a:tcPr>
-                    <a:solidFill>
-                      <a:srgbClr val="FFFFFF"/>
-                    </a:solidFill>
-                  </a:tcPr>
-                </a:tc>
-              </a:tr>
-              <a:tr h="701040">
-                <a:tc>
-                  <a:txBody>
-                    <a:bodyPr/>
-                    <a:lstStyle/>
-                    <a:p>
-                      <a:r>
-                        <a:rPr sz="1300">
-                          <a:solidFill>
-                            <a:srgbClr val="111827"/>
-                          </a:solidFill>
-                        </a:rPr>
-                        <a:t>Awa</a:t>
-                      </a:r>
-                    </a:p>
-                  </a:txBody>
-                  <a:tcPr>
-                    <a:solidFill>
-                      <a:srgbClr val="FFFFFF"/>
-                    </a:solidFill>
-                  </a:tcPr>
-                </a:tc>
-                <a:tc>
-                  <a:txBody>
-                    <a:bodyPr/>
-                    <a:lstStyle/>
-                    <a:p>
-                      <a:r>
-                        <a:rPr sz="1300">
-                          <a:solidFill>
-                            <a:srgbClr val="111827"/>
-                          </a:solidFill>
-                        </a:rPr>
-                        <a:t>Logique d'achat, stock, vues et formulaires.</a:t>
-                      </a:r>
-                    </a:p>
-                  </a:txBody>
-                  <a:tcPr>
-                    <a:solidFill>
-                      <a:srgbClr val="FFFFFF"/>
-                    </a:solidFill>
-                  </a:tcPr>
-                </a:tc>
-              </a:tr>
-              <a:tr h="701040">
-                <a:tc>
-                  <a:txBody>
-                    <a:bodyPr/>
-                    <a:lstStyle/>
-                    <a:p>
-                      <a:r>
-                        <a:rPr sz="1300">
-                          <a:solidFill>
-                            <a:srgbClr val="111827"/>
-                          </a:solidFill>
-                        </a:rPr>
-                        <a:t>Alexis</a:t>
-                      </a:r>
-                    </a:p>
-                  </a:txBody>
-                  <a:tcPr>
-                    <a:solidFill>
-                      <a:srgbClr val="FFFFFF"/>
-                    </a:solidFill>
-                  </a:tcPr>
-                </a:tc>
-                <a:tc>
-                  <a:txBody>
-                    <a:bodyPr/>
-                    <a:lstStyle/>
-                    <a:p>
-                      <a:r>
-                        <a:rPr sz="1300">
-                          <a:solidFill>
-                            <a:srgbClr val="111827"/>
-                          </a:solidFill>
-                        </a:rPr>
-                        <a:t>Templates HTML, CSS, JavaScript et rendu visuel.</a:t>
-                      </a:r>
-                    </a:p>
-                  </a:txBody>
-                  <a:tcPr>
-                    <a:solidFill>
-                      <a:srgbClr val="FFFFFF"/>
-                    </a:solidFill>
-                  </a:tcPr>
-                </a:tc>
-              </a:tr>
-              <a:tr h="701040">
-                <a:tc>
-                  <a:txBody>
-                    <a:bodyPr/>
-                    <a:lstStyle/>
-                    <a:p>
-                      <a:r>
-                        <a:rPr sz="1300">
-                          <a:solidFill>
-                            <a:srgbClr val="111827"/>
-                          </a:solidFill>
-                        </a:rPr>
-                        <a:t>Chloe</a:t>
-                      </a:r>
-                    </a:p>
-                  </a:txBody>
-                  <a:tcPr>
-                    <a:solidFill>
-                      <a:srgbClr val="FFFFFF"/>
-                    </a:solidFill>
-                  </a:tcPr>
-                </a:tc>
-                <a:tc>
-                  <a:txBody>
-                    <a:bodyPr/>
-                    <a:lstStyle/>
-                    <a:p>
-                      <a:r>
-                        <a:rPr sz="1300">
-                          <a:solidFill>
-                            <a:srgbClr val="111827"/>
-                          </a:solidFill>
-                        </a:rPr>
-                        <a:t>Jeux de donnees, images, tests et contenu de presentation.</a:t>
-                      </a:r>
-                    </a:p>
-                  </a:txBody>
-                  <a:tcPr>
-                    <a:solidFill>
-                      <a:srgbClr val="FFFFFF"/>
-                    </a:solidFill>
-                  </a:tcPr>
-                </a:tc>
-              </a:tr>
-            </a:tbl>
-          </a:graphicData>
-        </a:graphic>
-      </p:graphicFrame>
+        </p:nvSpPr>
+        <p:spPr>
+          <a:xfrm>
+            <a:off x="822960" y="1371600"/>
+            <a:ext cx="10332720" cy="4480560"/>
+          </a:xfrm>
+          <a:prstGeom prst="rect">
+            <a:avLst/>
+          </a:prstGeom>
+          <a:noFill/>
+        </p:spPr>
+        <p:txBody>
+          <a:bodyPr wrap="square">
+            <a:spAutoFit/>
+          </a:bodyPr>
+          <a:lstStyle/>
+          <a:p>
+            <a:pPr>
+              <a:spcAft>
+                <a:spcPts val="700"/>
+              </a:spcAft>
+              <a:defRPr sz="1700">
+                <a:solidFill>
+                  <a:srgbClr val="111827"/>
+                </a:solidFill>
+              </a:defRPr>
+            </a:pPr>
+            <a:r>
+              <a:t>models.py : definit la table Article avec designation, representation, stock, prix et categorie.</a:t>
+            </a:r>
+          </a:p>
+          <a:p>
+            <a:pPr>
+              <a:spcAft>
+                <a:spcPts val="700"/>
+              </a:spcAft>
+              <a:defRPr sz="1700">
+                <a:solidFill>
+                  <a:srgbClr val="111827"/>
+                </a:solidFill>
+              </a:defRPr>
+            </a:pPr>
+            <a:r>
+              <a:t>views.py : gere les pages, l'achat, les redirections et les messages.</a:t>
+            </a:r>
+          </a:p>
+          <a:p>
+            <a:pPr>
+              <a:spcAft>
+                <a:spcPts val="700"/>
+              </a:spcAft>
+              <a:defRPr sz="1700">
+                <a:solidFill>
+                  <a:srgbClr val="111827"/>
+                </a:solidFill>
+              </a:defRPr>
+            </a:pPr>
+            <a:r>
+              <a:t>forms.py : controle les saisies utilisateur et admin.</a:t>
+            </a:r>
+          </a:p>
+          <a:p>
+            <a:pPr>
+              <a:spcAft>
+                <a:spcPts val="700"/>
+              </a:spcAft>
+              <a:defRPr sz="1700">
+                <a:solidFill>
+                  <a:srgbClr val="111827"/>
+                </a:solidFill>
+              </a:defRPr>
+            </a:pPr>
+            <a:r>
+              <a:t>templates/ : affichent les pages visibles par le client et l'admin.</a:t>
+            </a:r>
+          </a:p>
+          <a:p>
+            <a:pPr>
+              <a:spcAft>
+                <a:spcPts val="700"/>
+              </a:spcAft>
+              <a:defRPr sz="1700">
+                <a:solidFill>
+                  <a:srgbClr val="111827"/>
+                </a:solidFill>
+              </a:defRPr>
+            </a:pPr>
+            <a:r>
+              <a:t>admin.py : personnalise l'administration Django.</a:t>
+            </a:r>
+          </a:p>
+          <a:p>
+            <a:pPr>
+              <a:spcAft>
+                <a:spcPts val="700"/>
+              </a:spcAft>
+              <a:defRPr sz="1700">
+                <a:solidFill>
+                  <a:srgbClr val="111827"/>
+                </a:solidFill>
+              </a:defRPr>
+            </a:pPr>
+            <a:r>
+              <a:t>tests.py : verifie les parcours importants.</a:t>
+            </a:r>
+          </a:p>
+        </p:txBody>
+      </p:sp>
     </p:spTree>
   </p:cSld>
   <p:clrMapOvr>
@@ -4845,7 +5801,7 @@
         <p:spPr>
           <a:xfrm>
             <a:off x="0" y="0"/>
-            <a:ext cx="12191695" cy="960120"/>
+            <a:ext cx="12191695" cy="914400"/>
           </a:xfrm>
           <a:prstGeom prst="rect">
             <a:avLst/>
@@ -4887,8 +5843,8 @@
         </p:nvSpPr>
         <p:spPr>
           <a:xfrm>
-            <a:off x="548640" y="201168"/>
-            <a:ext cx="7863840" cy="320040"/>
+            <a:off x="548640" y="182880"/>
+            <a:ext cx="8961120" cy="320040"/>
           </a:xfrm>
           <a:prstGeom prst="rect">
             <a:avLst/>
@@ -4902,26 +5858,385 @@
           <a:lstStyle/>
           <a:p>
             <a:r>
-              <a:rPr sz="2600" b="1">
+              <a:rPr sz="2400" b="1">
                 <a:solidFill>
                   <a:srgbClr val="FFFFFF"/>
                 </a:solidFill>
               </a:rPr>
-              <a:t>Conclusion</a:t>
-            </a:r>
-          </a:p>
-        </p:txBody>
-      </p:sp>
-      <p:sp>
-        <p:nvSpPr>
-          <p:cNvPr id="4" name="TextBox 3"/>
+              <a:t>Repartition du travail</a:t>
+            </a:r>
+          </a:p>
+        </p:txBody>
+      </p:sp>
+      <p:graphicFrame>
+        <p:nvGraphicFramePr>
+          <p:cNvPr id="4" name="Table 3"/>
+          <p:cNvGraphicFramePr>
+            <a:graphicFrameLocks noGrp="1"/>
+          </p:cNvGraphicFramePr>
+          <p:nvPr/>
+        </p:nvGraphicFramePr>
+        <p:xfrm>
+          <a:off x="777240" y="1417320"/>
+          <a:ext cx="10698480" cy="4297680"/>
+        </p:xfrm>
+        <a:graphic>
+          <a:graphicData uri="http://schemas.openxmlformats.org/drawingml/2006/table">
+            <a:tbl>
+              <a:tblPr firstRow="1" bandRow="1">
+                <a:tableStyleId>{5C22544A-7EE6-4342-B048-85BDC9FD1C3A}</a:tableStyleId>
+              </a:tblPr>
+              <a:tblGrid>
+                <a:gridCol w="2011680"/>
+                <a:gridCol w="8686800"/>
+              </a:tblGrid>
+              <a:tr h="716280">
+                <a:tc>
+                  <a:txBody>
+                    <a:bodyPr/>
+                    <a:lstStyle/>
+                    <a:p>
+                      <a:r>
+                        <a:rPr sz="1200" b="1">
+                          <a:solidFill>
+                            <a:srgbClr val="FFFFFF"/>
+                          </a:solidFill>
+                        </a:rPr>
+                        <a:t>Membre</a:t>
+                      </a:r>
+                    </a:p>
+                  </a:txBody>
+                  <a:tcPr>
+                    <a:solidFill>
+                      <a:srgbClr val="111827"/>
+                    </a:solidFill>
+                  </a:tcPr>
+                </a:tc>
+                <a:tc>
+                  <a:txBody>
+                    <a:bodyPr/>
+                    <a:lstStyle/>
+                    <a:p>
+                      <a:r>
+                        <a:rPr sz="1200" b="1">
+                          <a:solidFill>
+                            <a:srgbClr val="FFFFFF"/>
+                          </a:solidFill>
+                        </a:rPr>
+                        <a:t>Contribution principale</a:t>
+                      </a:r>
+                    </a:p>
+                  </a:txBody>
+                  <a:tcPr>
+                    <a:solidFill>
+                      <a:srgbClr val="111827"/>
+                    </a:solidFill>
+                  </a:tcPr>
+                </a:tc>
+              </a:tr>
+              <a:tr h="716280">
+                <a:tc>
+                  <a:txBody>
+                    <a:bodyPr/>
+                    <a:lstStyle/>
+                    <a:p>
+                      <a:r>
+                        <a:rPr sz="1300" b="0">
+                          <a:solidFill>
+                            <a:srgbClr val="111827"/>
+                          </a:solidFill>
+                        </a:rPr>
+                        <a:t>Zeinabou</a:t>
+                      </a:r>
+                    </a:p>
+                  </a:txBody>
+                  <a:tcPr>
+                    <a:solidFill>
+                      <a:srgbClr val="FFFFFF"/>
+                    </a:solidFill>
+                  </a:tcPr>
+                </a:tc>
+                <a:tc>
+                  <a:txBody>
+                    <a:bodyPr/>
+                    <a:lstStyle/>
+                    <a:p>
+                      <a:r>
+                        <a:rPr sz="1300" b="0">
+                          <a:solidFill>
+                            <a:srgbClr val="111827"/>
+                          </a:solidFill>
+                        </a:rPr>
+                        <a:t>Structure du projet, URLs, integration finale, verification.</a:t>
+                      </a:r>
+                    </a:p>
+                  </a:txBody>
+                  <a:tcPr>
+                    <a:solidFill>
+                      <a:srgbClr val="FFFFFF"/>
+                    </a:solidFill>
+                  </a:tcPr>
+                </a:tc>
+              </a:tr>
+              <a:tr h="716280">
+                <a:tc>
+                  <a:txBody>
+                    <a:bodyPr/>
+                    <a:lstStyle/>
+                    <a:p>
+                      <a:r>
+                        <a:rPr sz="1300" b="0">
+                          <a:solidFill>
+                            <a:srgbClr val="111827"/>
+                          </a:solidFill>
+                        </a:rPr>
+                        <a:t>Assia</a:t>
+                      </a:r>
+                    </a:p>
+                  </a:txBody>
+                  <a:tcPr>
+                    <a:solidFill>
+                      <a:srgbClr val="FFFFFF"/>
+                    </a:solidFill>
+                  </a:tcPr>
+                </a:tc>
+                <a:tc>
+                  <a:txBody>
+                    <a:bodyPr/>
+                    <a:lstStyle/>
+                    <a:p>
+                      <a:r>
+                        <a:rPr sz="1300" b="0">
+                          <a:solidFill>
+                            <a:srgbClr val="111827"/>
+                          </a:solidFill>
+                        </a:rPr>
+                        <a:t>Modele Article, base de donnees, categories, administration.</a:t>
+                      </a:r>
+                    </a:p>
+                  </a:txBody>
+                  <a:tcPr>
+                    <a:solidFill>
+                      <a:srgbClr val="FFFFFF"/>
+                    </a:solidFill>
+                  </a:tcPr>
+                </a:tc>
+              </a:tr>
+              <a:tr h="716280">
+                <a:tc>
+                  <a:txBody>
+                    <a:bodyPr/>
+                    <a:lstStyle/>
+                    <a:p>
+                      <a:r>
+                        <a:rPr sz="1300" b="0">
+                          <a:solidFill>
+                            <a:srgbClr val="111827"/>
+                          </a:solidFill>
+                        </a:rPr>
+                        <a:t>Awa</a:t>
+                      </a:r>
+                    </a:p>
+                  </a:txBody>
+                  <a:tcPr>
+                    <a:solidFill>
+                      <a:srgbClr val="FFFFFF"/>
+                    </a:solidFill>
+                  </a:tcPr>
+                </a:tc>
+                <a:tc>
+                  <a:txBody>
+                    <a:bodyPr/>
+                    <a:lstStyle/>
+                    <a:p>
+                      <a:r>
+                        <a:rPr sz="1300" b="0">
+                          <a:solidFill>
+                            <a:srgbClr val="111827"/>
+                          </a:solidFill>
+                        </a:rPr>
+                        <a:t>Logique d'achat, stock, vues et formulaires.</a:t>
+                      </a:r>
+                    </a:p>
+                  </a:txBody>
+                  <a:tcPr>
+                    <a:solidFill>
+                      <a:srgbClr val="FFFFFF"/>
+                    </a:solidFill>
+                  </a:tcPr>
+                </a:tc>
+              </a:tr>
+              <a:tr h="716280">
+                <a:tc>
+                  <a:txBody>
+                    <a:bodyPr/>
+                    <a:lstStyle/>
+                    <a:p>
+                      <a:r>
+                        <a:rPr sz="1300" b="0">
+                          <a:solidFill>
+                            <a:srgbClr val="111827"/>
+                          </a:solidFill>
+                        </a:rPr>
+                        <a:t>Alexis</a:t>
+                      </a:r>
+                    </a:p>
+                  </a:txBody>
+                  <a:tcPr>
+                    <a:solidFill>
+                      <a:srgbClr val="FFFFFF"/>
+                    </a:solidFill>
+                  </a:tcPr>
+                </a:tc>
+                <a:tc>
+                  <a:txBody>
+                    <a:bodyPr/>
+                    <a:lstStyle/>
+                    <a:p>
+                      <a:r>
+                        <a:rPr sz="1300" b="0">
+                          <a:solidFill>
+                            <a:srgbClr val="111827"/>
+                          </a:solidFill>
+                        </a:rPr>
+                        <a:t>Templates HTML, CSS, JavaScript, interface visuelle.</a:t>
+                      </a:r>
+                    </a:p>
+                  </a:txBody>
+                  <a:tcPr>
+                    <a:solidFill>
+                      <a:srgbClr val="FFFFFF"/>
+                    </a:solidFill>
+                  </a:tcPr>
+                </a:tc>
+              </a:tr>
+              <a:tr h="716280">
+                <a:tc>
+                  <a:txBody>
+                    <a:bodyPr/>
+                    <a:lstStyle/>
+                    <a:p>
+                      <a:r>
+                        <a:rPr sz="1300" b="0">
+                          <a:solidFill>
+                            <a:srgbClr val="111827"/>
+                          </a:solidFill>
+                        </a:rPr>
+                        <a:t>Chloe</a:t>
+                      </a:r>
+                    </a:p>
+                  </a:txBody>
+                  <a:tcPr>
+                    <a:solidFill>
+                      <a:srgbClr val="FFFFFF"/>
+                    </a:solidFill>
+                  </a:tcPr>
+                </a:tc>
+                <a:tc>
+                  <a:txBody>
+                    <a:bodyPr/>
+                    <a:lstStyle/>
+                    <a:p>
+                      <a:r>
+                        <a:rPr sz="1300" b="0">
+                          <a:solidFill>
+                            <a:srgbClr val="111827"/>
+                          </a:solidFill>
+                        </a:rPr>
+                        <a:t>Donnees de demo, tests, captures et documentation.</a:t>
+                      </a:r>
+                    </a:p>
+                  </a:txBody>
+                  <a:tcPr>
+                    <a:solidFill>
+                      <a:srgbClr val="FFFFFF"/>
+                    </a:solidFill>
+                  </a:tcPr>
+                </a:tc>
+              </a:tr>
+            </a:tbl>
+          </a:graphicData>
+        </a:graphic>
+      </p:graphicFrame>
+    </p:spTree>
+  </p:cSld>
+  <p:clrMapOvr>
+    <a:masterClrMapping/>
+  </p:clrMapOvr>
+</p:sld>
+</file>
+
+<file path=ppt/slides/slide8.xml><?xml version="1.0" encoding="utf-8"?>
+<p:sld xmlns:a="http://schemas.openxmlformats.org/drawingml/2006/main" xmlns:p="http://schemas.openxmlformats.org/presentationml/2006/main" xmlns:r="http://schemas.openxmlformats.org/officeDocument/2006/relationships">
+  <p:cSld>
+    <p:bg>
+      <p:bgPr>
+        <a:solidFill>
+          <a:srgbClr val="F7F9FC"/>
+        </a:solidFill>
+        <a:effectLst/>
+      </p:bgPr>
+    </p:bg>
+    <p:spTree>
+      <p:nvGrpSpPr>
+        <p:cNvPr id="1" name=""/>
+        <p:cNvGrpSpPr/>
+        <p:nvPr/>
+      </p:nvGrpSpPr>
+      <p:grpSpPr/>
+      <p:sp>
+        <p:nvSpPr>
+          <p:cNvPr id="2" name="Rectangle 1"/>
+          <p:cNvSpPr/>
+          <p:nvPr/>
+        </p:nvSpPr>
+        <p:spPr>
+          <a:xfrm>
+            <a:off x="0" y="0"/>
+            <a:ext cx="12191695" cy="914400"/>
+          </a:xfrm>
+          <a:prstGeom prst="rect">
+            <a:avLst/>
+          </a:prstGeom>
+          <a:solidFill>
+            <a:srgbClr val="111827"/>
+          </a:solidFill>
+          <a:ln>
+            <a:noFill/>
+          </a:ln>
+        </p:spPr>
+        <p:style>
+          <a:lnRef idx="1">
+            <a:schemeClr val="accent1"/>
+          </a:lnRef>
+          <a:fillRef idx="3">
+            <a:schemeClr val="accent1"/>
+          </a:fillRef>
+          <a:effectRef idx="2">
+            <a:schemeClr val="accent1"/>
+          </a:effectRef>
+          <a:fontRef idx="minor">
+            <a:schemeClr val="lt1"/>
+          </a:fontRef>
+        </p:style>
+        <p:txBody>
+          <a:bodyPr rtlCol="0" anchor="ctr"/>
+          <a:lstStyle/>
+          <a:p>
+            <a:pPr algn="ctr"/>
+          </a:p>
+        </p:txBody>
+      </p:sp>
+      <p:sp>
+        <p:nvSpPr>
+          <p:cNvPr id="3" name="TextBox 2"/>
           <p:cNvSpPr txBox="1"/>
           <p:nvPr/>
         </p:nvSpPr>
         <p:spPr>
           <a:xfrm>
-            <a:off x="777240" y="1463040"/>
-            <a:ext cx="10515600" cy="3108960"/>
+            <a:off x="548640" y="182880"/>
+            <a:ext cx="8961120" cy="320040"/>
           </a:xfrm>
           <a:prstGeom prst="rect">
             <a:avLst/>
@@ -4929,82 +6244,32 @@
           <a:noFill/>
         </p:spPr>
         <p:txBody>
-          <a:bodyPr wrap="square">
+          <a:bodyPr wrap="none">
             <a:spAutoFit/>
           </a:bodyPr>
           <a:lstStyle/>
           <a:p>
-            <a:pPr>
-              <a:spcAft>
-                <a:spcPts val="800"/>
-              </a:spcAft>
-              <a:defRPr sz="2000">
-                <a:solidFill>
-                  <a:srgbClr val="111827"/>
-                </a:solidFill>
-              </a:defRPr>
-            </a:pPr>
-            <a:r>
-              <a:t>Le site repond au cahier des charges du cours.</a:t>
-            </a:r>
-          </a:p>
-          <a:p>
-            <a:pPr>
-              <a:spcAft>
-                <a:spcPts val="800"/>
-              </a:spcAft>
-              <a:defRPr sz="2000">
-                <a:solidFill>
-                  <a:srgbClr val="111827"/>
-                </a:solidFill>
-              </a:defRPr>
-            </a:pPr>
-            <a:r>
-              <a:t>Les deux roles sont fonctionnels : client et administrateur.</a:t>
-            </a:r>
-          </a:p>
-          <a:p>
-            <a:pPr>
-              <a:spcAft>
-                <a:spcPts val="800"/>
-              </a:spcAft>
-              <a:defRPr sz="2000">
-                <a:solidFill>
-                  <a:srgbClr val="111827"/>
-                </a:solidFill>
-              </a:defRPr>
-            </a:pPr>
-            <a:r>
-              <a:t>Le stock est mis a jour automatiquement apres achat.</a:t>
-            </a:r>
-          </a:p>
-          <a:p>
-            <a:pPr>
-              <a:spcAft>
-                <a:spcPts val="800"/>
-              </a:spcAft>
-              <a:defRPr sz="2000">
-                <a:solidFill>
-                  <a:srgbClr val="111827"/>
-                </a:solidFill>
-              </a:defRPr>
-            </a:pPr>
-            <a:r>
-              <a:t>Le projet est teste, documente et pret pour la soutenance.</a:t>
-            </a:r>
-          </a:p>
-        </p:txBody>
-      </p:sp>
-      <p:sp>
-        <p:nvSpPr>
-          <p:cNvPr id="5" name="TextBox 4"/>
+            <a:r>
+              <a:rPr sz="2400" b="1">
+                <a:solidFill>
+                  <a:srgbClr val="FFFFFF"/>
+                </a:solidFill>
+              </a:rPr>
+              <a:t>Choix de design</a:t>
+            </a:r>
+          </a:p>
+        </p:txBody>
+      </p:sp>
+      <p:sp>
+        <p:nvSpPr>
+          <p:cNvPr id="4" name="TextBox 3"/>
           <p:cNvSpPr txBox="1"/>
           <p:nvPr/>
         </p:nvSpPr>
         <p:spPr>
           <a:xfrm>
-            <a:off x="777240" y="5166360"/>
-            <a:ext cx="10424160" cy="640080"/>
+            <a:off x="822960" y="1371600"/>
+            <a:ext cx="5303520" cy="4389120"/>
           </a:xfrm>
           <a:prstGeom prst="rect">
             <a:avLst/>
@@ -5012,19 +6277,381 @@
           <a:noFill/>
         </p:spPr>
         <p:txBody>
+          <a:bodyPr wrap="square">
+            <a:spAutoFit/>
+          </a:bodyPr>
+          <a:lstStyle/>
+          <a:p>
+            <a:pPr>
+              <a:spcAft>
+                <a:spcPts val="700"/>
+              </a:spcAft>
+              <a:defRPr sz="1800">
+                <a:solidFill>
+                  <a:srgbClr val="111827"/>
+                </a:solidFill>
+              </a:defRPr>
+            </a:pPr>
+            <a:r>
+              <a:t>Interface claire et moderne inspiree d'un site e-commerce de vetements.</a:t>
+            </a:r>
+          </a:p>
+          <a:p>
+            <a:pPr>
+              <a:spcAft>
+                <a:spcPts val="700"/>
+              </a:spcAft>
+              <a:defRPr sz="1800">
+                <a:solidFill>
+                  <a:srgbClr val="111827"/>
+                </a:solidFill>
+              </a:defRPr>
+            </a:pPr>
+            <a:r>
+              <a:t>Palette sobre pour mettre en avant les produits.</a:t>
+            </a:r>
+          </a:p>
+          <a:p>
+            <a:pPr>
+              <a:spcAft>
+                <a:spcPts val="700"/>
+              </a:spcAft>
+              <a:defRPr sz="1800">
+                <a:solidFill>
+                  <a:srgbClr val="111827"/>
+                </a:solidFill>
+              </a:defRPr>
+            </a:pPr>
+            <a:r>
+              <a:t>Grille de cartes pour lire vite l'image, le prix et le stock.</a:t>
+            </a:r>
+          </a:p>
+          <a:p>
+            <a:pPr>
+              <a:spcAft>
+                <a:spcPts val="700"/>
+              </a:spcAft>
+              <a:defRPr sz="1800">
+                <a:solidFill>
+                  <a:srgbClr val="111827"/>
+                </a:solidFill>
+              </a:defRPr>
+            </a:pPr>
+            <a:r>
+              <a:t>Navigation simple entre accueil, catalogue, login et gestion.</a:t>
+            </a:r>
+          </a:p>
+        </p:txBody>
+      </p:sp>
+      <p:sp>
+        <p:nvSpPr>
+          <p:cNvPr id="5" name="TextBox 4"/>
+          <p:cNvSpPr txBox="1"/>
+          <p:nvPr/>
+        </p:nvSpPr>
+        <p:spPr>
+          <a:xfrm>
+            <a:off x="6035040" y="1371600"/>
+            <a:ext cx="5029200" cy="4389120"/>
+          </a:xfrm>
+          <a:prstGeom prst="rect">
+            <a:avLst/>
+          </a:prstGeom>
+          <a:noFill/>
+        </p:spPr>
+        <p:txBody>
+          <a:bodyPr wrap="square">
+            <a:spAutoFit/>
+          </a:bodyPr>
+          <a:lstStyle/>
+          <a:p>
+            <a:pPr>
+              <a:spcAft>
+                <a:spcPts val="700"/>
+              </a:spcAft>
+              <a:defRPr sz="1800">
+                <a:solidFill>
+                  <a:srgbClr val="111827"/>
+                </a:solidFill>
+              </a:defRPr>
+            </a:pPr>
+            <a:r>
+              <a:t>Nous n'avons pas choisi un design trop charge.</a:t>
+            </a:r>
+          </a:p>
+          <a:p>
+            <a:pPr>
+              <a:spcAft>
+                <a:spcPts val="700"/>
+              </a:spcAft>
+              <a:defRPr sz="1800">
+                <a:solidFill>
+                  <a:srgbClr val="111827"/>
+                </a:solidFill>
+              </a:defRPr>
+            </a:pPr>
+            <a:r>
+              <a:t>Le but etait d'etre lisible pour la demonstration.</a:t>
+            </a:r>
+          </a:p>
+          <a:p>
+            <a:pPr>
+              <a:spcAft>
+                <a:spcPts val="700"/>
+              </a:spcAft>
+              <a:defRPr sz="1800">
+                <a:solidFill>
+                  <a:srgbClr val="111827"/>
+                </a:solidFill>
+              </a:defRPr>
+            </a:pPr>
+            <a:r>
+              <a:t>La priorite est restee la fonctionnalite du projet.</a:t>
+            </a:r>
+          </a:p>
+          <a:p>
+            <a:pPr>
+              <a:spcAft>
+                <a:spcPts val="700"/>
+              </a:spcAft>
+              <a:defRPr sz="1800">
+                <a:solidFill>
+                  <a:srgbClr val="111827"/>
+                </a:solidFill>
+              </a:defRPr>
+            </a:pPr>
+            <a:r>
+              <a:t>Le design soutient la demo sans compliquer l'utilisation.</a:t>
+            </a:r>
+          </a:p>
+        </p:txBody>
+      </p:sp>
+    </p:spTree>
+  </p:cSld>
+  <p:clrMapOvr>
+    <a:masterClrMapping/>
+  </p:clrMapOvr>
+</p:sld>
+</file>
+
+<file path=ppt/slides/slide9.xml><?xml version="1.0" encoding="utf-8"?>
+<p:sld xmlns:a="http://schemas.openxmlformats.org/drawingml/2006/main" xmlns:p="http://schemas.openxmlformats.org/presentationml/2006/main" xmlns:r="http://schemas.openxmlformats.org/officeDocument/2006/relationships">
+  <p:cSld>
+    <p:bg>
+      <p:bgPr>
+        <a:solidFill>
+          <a:srgbClr val="F7F9FC"/>
+        </a:solidFill>
+        <a:effectLst/>
+      </p:bgPr>
+    </p:bg>
+    <p:spTree>
+      <p:nvGrpSpPr>
+        <p:cNvPr id="1" name=""/>
+        <p:cNvGrpSpPr/>
+        <p:nvPr/>
+      </p:nvGrpSpPr>
+      <p:grpSpPr/>
+      <p:sp>
+        <p:nvSpPr>
+          <p:cNvPr id="2" name="Rectangle 1"/>
+          <p:cNvSpPr/>
+          <p:nvPr/>
+        </p:nvSpPr>
+        <p:spPr>
+          <a:xfrm>
+            <a:off x="0" y="0"/>
+            <a:ext cx="12191695" cy="914400"/>
+          </a:xfrm>
+          <a:prstGeom prst="rect">
+            <a:avLst/>
+          </a:prstGeom>
+          <a:solidFill>
+            <a:srgbClr val="111827"/>
+          </a:solidFill>
+          <a:ln>
+            <a:noFill/>
+          </a:ln>
+        </p:spPr>
+        <p:style>
+          <a:lnRef idx="1">
+            <a:schemeClr val="accent1"/>
+          </a:lnRef>
+          <a:fillRef idx="3">
+            <a:schemeClr val="accent1"/>
+          </a:fillRef>
+          <a:effectRef idx="2">
+            <a:schemeClr val="accent1"/>
+          </a:effectRef>
+          <a:fontRef idx="minor">
+            <a:schemeClr val="lt1"/>
+          </a:fontRef>
+        </p:style>
+        <p:txBody>
+          <a:bodyPr rtlCol="0" anchor="ctr"/>
+          <a:lstStyle/>
+          <a:p>
+            <a:pPr algn="ctr"/>
+          </a:p>
+        </p:txBody>
+      </p:sp>
+      <p:sp>
+        <p:nvSpPr>
+          <p:cNvPr id="3" name="TextBox 2"/>
+          <p:cNvSpPr txBox="1"/>
+          <p:nvPr/>
+        </p:nvSpPr>
+        <p:spPr>
+          <a:xfrm>
+            <a:off x="548640" y="182880"/>
+            <a:ext cx="8961120" cy="320040"/>
+          </a:xfrm>
+          <a:prstGeom prst="rect">
+            <a:avLst/>
+          </a:prstGeom>
+          <a:noFill/>
+        </p:spPr>
+        <p:txBody>
           <a:bodyPr wrap="none">
             <a:spAutoFit/>
           </a:bodyPr>
           <a:lstStyle/>
           <a:p>
-            <a:pPr algn="ctr"/>
-            <a:r>
-              <a:rPr sz="1800" b="1">
-                <a:solidFill>
-                  <a:srgbClr val="2563EB"/>
+            <a:r>
+              <a:rPr sz="2400" b="1">
+                <a:solidFill>
+                  <a:srgbClr val="FFFFFF"/>
                 </a:solidFill>
               </a:rPr>
-              <a:t>Comptes de demonstration : admin / admin123   |   client1 / client123</a:t>
+              <a:t>Demonstration prevue</a:t>
+            </a:r>
+          </a:p>
+        </p:txBody>
+      </p:sp>
+      <p:sp>
+        <p:nvSpPr>
+          <p:cNvPr id="4" name="TextBox 3"/>
+          <p:cNvSpPr txBox="1"/>
+          <p:nvPr/>
+        </p:nvSpPr>
+        <p:spPr>
+          <a:xfrm>
+            <a:off x="822960" y="1325880"/>
+            <a:ext cx="10424160" cy="4572000"/>
+          </a:xfrm>
+          <a:prstGeom prst="rect">
+            <a:avLst/>
+          </a:prstGeom>
+          <a:noFill/>
+        </p:spPr>
+        <p:txBody>
+          <a:bodyPr wrap="square">
+            <a:spAutoFit/>
+          </a:bodyPr>
+          <a:lstStyle/>
+          <a:p>
+            <a:pPr>
+              <a:spcAft>
+                <a:spcPts val="700"/>
+              </a:spcAft>
+              <a:defRPr sz="1800">
+                <a:solidFill>
+                  <a:srgbClr val="111827"/>
+                </a:solidFill>
+              </a:defRPr>
+            </a:pPr>
+            <a:r>
+              <a:t>Ouvrir l'accueil puis le catalogue.</a:t>
+            </a:r>
+          </a:p>
+          <a:p>
+            <a:pPr>
+              <a:spcAft>
+                <a:spcPts val="700"/>
+              </a:spcAft>
+              <a:defRPr sz="1800">
+                <a:solidFill>
+                  <a:srgbClr val="111827"/>
+                </a:solidFill>
+              </a:defRPr>
+            </a:pPr>
+            <a:r>
+              <a:t>Montrer les categories homme, femme et enfant.</a:t>
+            </a:r>
+          </a:p>
+          <a:p>
+            <a:pPr>
+              <a:spcAft>
+                <a:spcPts val="700"/>
+              </a:spcAft>
+              <a:defRPr sz="1800">
+                <a:solidFill>
+                  <a:srgbClr val="111827"/>
+                </a:solidFill>
+              </a:defRPr>
+            </a:pPr>
+            <a:r>
+              <a:t>Se connecter en client avec client1 / client123.</a:t>
+            </a:r>
+          </a:p>
+          <a:p>
+            <a:pPr>
+              <a:spcAft>
+                <a:spcPts val="700"/>
+              </a:spcAft>
+              <a:defRPr sz="1800">
+                <a:solidFill>
+                  <a:srgbClr val="111827"/>
+                </a:solidFill>
+              </a:defRPr>
+            </a:pPr>
+            <a:r>
+              <a:t>Acheter un article et montrer le message de confirmation.</a:t>
+            </a:r>
+          </a:p>
+          <a:p>
+            <a:pPr>
+              <a:spcAft>
+                <a:spcPts val="700"/>
+              </a:spcAft>
+              <a:defRPr sz="1800">
+                <a:solidFill>
+                  <a:srgbClr val="111827"/>
+                </a:solidFill>
+              </a:defRPr>
+            </a:pPr>
+            <a:r>
+              <a:t>Verifier que le stock a baisse.</a:t>
+            </a:r>
+          </a:p>
+          <a:p>
+            <a:pPr>
+              <a:spcAft>
+                <a:spcPts val="700"/>
+              </a:spcAft>
+              <a:defRPr sz="1800">
+                <a:solidFill>
+                  <a:srgbClr val="111827"/>
+                </a:solidFill>
+              </a:defRPr>
+            </a:pPr>
+            <a:r>
+              <a:t>Se connecter en admin avec admin / admin123.</a:t>
+            </a:r>
+          </a:p>
+          <a:p>
+            <a:pPr>
+              <a:spcAft>
+                <a:spcPts val="700"/>
+              </a:spcAft>
+              <a:defRPr sz="1800">
+                <a:solidFill>
+                  <a:srgbClr val="111827"/>
+                </a:solidFill>
+              </a:defRPr>
+            </a:pPr>
+            <a:r>
+              <a:t>Montrer l'ajout, la modification ou la suppression d'un article.</a:t>
             </a:r>
           </a:p>
         </p:txBody>

</xml_diff>